<commit_message>
add parameter `cbar_height` & update docs
</commit_message>
<xml_diff>
--- a/docs/images/gallery1.pptx
+++ b/docs/images/gallery1.pptx
@@ -2,12 +2,12 @@
 <file path=ppt/presentation.xml><?xml version="1.0" encoding="utf-8"?>
 <p:presentation xmlns:a="http://schemas.openxmlformats.org/drawingml/2006/main" xmlns:r="http://schemas.openxmlformats.org/officeDocument/2006/relationships" xmlns:p="http://schemas.openxmlformats.org/presentationml/2006/main" saveSubsetFonts="1" autoCompressPictures="0">
   <p:sldMasterIdLst>
-    <p:sldMasterId id="2147483660" r:id="rId1"/>
+    <p:sldMasterId id="2147483708" r:id="rId1"/>
   </p:sldMasterIdLst>
   <p:sldIdLst>
     <p:sldId id="256" r:id="rId2"/>
   </p:sldIdLst>
-  <p:sldSz cx="6858000" cy="9144000" type="letter"/>
+  <p:sldSz cx="7920038" cy="7199313"/>
   <p:notesSz cx="9144000" cy="6858000"/>
   <p:defaultTextStyle>
     <a:defPPr>
@@ -141,15 +141,15 @@
         </p:nvSpPr>
         <p:spPr>
           <a:xfrm>
-            <a:off x="514350" y="1496484"/>
-            <a:ext cx="5829300" cy="3183467"/>
+            <a:off x="594003" y="1178222"/>
+            <a:ext cx="6732032" cy="2506427"/>
           </a:xfrm>
         </p:spPr>
         <p:txBody>
           <a:bodyPr anchor="b"/>
           <a:lstStyle>
             <a:lvl1pPr algn="ctr">
-              <a:defRPr sz="4500"/>
+              <a:defRPr sz="5197"/>
             </a:lvl1pPr>
           </a:lstStyle>
           <a:p>
@@ -173,8 +173,8 @@
         </p:nvSpPr>
         <p:spPr>
           <a:xfrm>
-            <a:off x="857250" y="4802717"/>
-            <a:ext cx="5143500" cy="2207683"/>
+            <a:off x="990005" y="3781306"/>
+            <a:ext cx="5940029" cy="1738167"/>
           </a:xfrm>
         </p:spPr>
         <p:txBody>
@@ -182,39 +182,39 @@
           <a:lstStyle>
             <a:lvl1pPr marL="0" indent="0" algn="ctr">
               <a:buNone/>
-              <a:defRPr sz="1800"/>
+              <a:defRPr sz="2079"/>
             </a:lvl1pPr>
-            <a:lvl2pPr marL="342900" indent="0" algn="ctr">
-              <a:buNone/>
-              <a:defRPr sz="1500"/>
+            <a:lvl2pPr marL="395981" indent="0" algn="ctr">
+              <a:buNone/>
+              <a:defRPr sz="1732"/>
             </a:lvl2pPr>
-            <a:lvl3pPr marL="685800" indent="0" algn="ctr">
-              <a:buNone/>
-              <a:defRPr sz="1350"/>
+            <a:lvl3pPr marL="791962" indent="0" algn="ctr">
+              <a:buNone/>
+              <a:defRPr sz="1559"/>
             </a:lvl3pPr>
-            <a:lvl4pPr marL="1028700" indent="0" algn="ctr">
-              <a:buNone/>
-              <a:defRPr sz="1200"/>
+            <a:lvl4pPr marL="1187943" indent="0" algn="ctr">
+              <a:buNone/>
+              <a:defRPr sz="1386"/>
             </a:lvl4pPr>
-            <a:lvl5pPr marL="1371600" indent="0" algn="ctr">
-              <a:buNone/>
-              <a:defRPr sz="1200"/>
+            <a:lvl5pPr marL="1583924" indent="0" algn="ctr">
+              <a:buNone/>
+              <a:defRPr sz="1386"/>
             </a:lvl5pPr>
-            <a:lvl6pPr marL="1714500" indent="0" algn="ctr">
-              <a:buNone/>
-              <a:defRPr sz="1200"/>
+            <a:lvl6pPr marL="1979905" indent="0" algn="ctr">
+              <a:buNone/>
+              <a:defRPr sz="1386"/>
             </a:lvl6pPr>
-            <a:lvl7pPr marL="2057400" indent="0" algn="ctr">
-              <a:buNone/>
-              <a:defRPr sz="1200"/>
+            <a:lvl7pPr marL="2375886" indent="0" algn="ctr">
+              <a:buNone/>
+              <a:defRPr sz="1386"/>
             </a:lvl7pPr>
-            <a:lvl8pPr marL="2400300" indent="0" algn="ctr">
-              <a:buNone/>
-              <a:defRPr sz="1200"/>
+            <a:lvl8pPr marL="2771866" indent="0" algn="ctr">
+              <a:buNone/>
+              <a:defRPr sz="1386"/>
             </a:lvl8pPr>
-            <a:lvl9pPr marL="2743200" indent="0" algn="ctr">
-              <a:buNone/>
-              <a:defRPr sz="1200"/>
+            <a:lvl9pPr marL="3167847" indent="0" algn="ctr">
+              <a:buNone/>
+              <a:defRPr sz="1386"/>
             </a:lvl9pPr>
           </a:lstStyle>
           <a:p>
@@ -243,7 +243,7 @@
           <a:p>
             <a:fld id="{CFD239F0-43B1-DD42-BACD-13F81CB3B2FE}" type="datetimeFigureOut">
               <a:rPr lang="en-US" smtClean="0"/>
-              <a:t>4/11/24</a:t>
+              <a:t>3/31/26</a:t>
             </a:fld>
             <a:endParaRPr lang="en-US"/>
           </a:p>
@@ -294,7 +294,7 @@
     </p:spTree>
     <p:extLst>
       <p:ext uri="{BB962C8B-B14F-4D97-AF65-F5344CB8AC3E}">
-        <p14:creationId xmlns:p14="http://schemas.microsoft.com/office/powerpoint/2010/main" val="2313820039"/>
+        <p14:creationId xmlns:p14="http://schemas.microsoft.com/office/powerpoint/2010/main" val="1977505421"/>
       </p:ext>
     </p:extLst>
   </p:cSld>
@@ -413,7 +413,7 @@
           <a:p>
             <a:fld id="{CFD239F0-43B1-DD42-BACD-13F81CB3B2FE}" type="datetimeFigureOut">
               <a:rPr lang="en-US" smtClean="0"/>
-              <a:t>4/11/24</a:t>
+              <a:t>3/31/26</a:t>
             </a:fld>
             <a:endParaRPr lang="en-US"/>
           </a:p>
@@ -464,7 +464,7 @@
     </p:spTree>
     <p:extLst>
       <p:ext uri="{BB962C8B-B14F-4D97-AF65-F5344CB8AC3E}">
-        <p14:creationId xmlns:p14="http://schemas.microsoft.com/office/powerpoint/2010/main" val="3975858142"/>
+        <p14:creationId xmlns:p14="http://schemas.microsoft.com/office/powerpoint/2010/main" val="4267795225"/>
       </p:ext>
     </p:extLst>
   </p:cSld>
@@ -503,8 +503,8 @@
         </p:nvSpPr>
         <p:spPr>
           <a:xfrm>
-            <a:off x="4907757" y="486834"/>
-            <a:ext cx="1478756" cy="7749117"/>
+            <a:off x="5667778" y="383297"/>
+            <a:ext cx="1707758" cy="6101085"/>
           </a:xfrm>
         </p:spPr>
         <p:txBody>
@@ -531,8 +531,8 @@
         </p:nvSpPr>
         <p:spPr>
           <a:xfrm>
-            <a:off x="471488" y="486834"/>
-            <a:ext cx="4350544" cy="7749117"/>
+            <a:off x="544503" y="383297"/>
+            <a:ext cx="5024274" cy="6101085"/>
           </a:xfrm>
         </p:spPr>
         <p:txBody>
@@ -593,7 +593,7 @@
           <a:p>
             <a:fld id="{CFD239F0-43B1-DD42-BACD-13F81CB3B2FE}" type="datetimeFigureOut">
               <a:rPr lang="en-US" smtClean="0"/>
-              <a:t>4/11/24</a:t>
+              <a:t>3/31/26</a:t>
             </a:fld>
             <a:endParaRPr lang="en-US"/>
           </a:p>
@@ -644,7 +644,7 @@
     </p:spTree>
     <p:extLst>
       <p:ext uri="{BB962C8B-B14F-4D97-AF65-F5344CB8AC3E}">
-        <p14:creationId xmlns:p14="http://schemas.microsoft.com/office/powerpoint/2010/main" val="4078178456"/>
+        <p14:creationId xmlns:p14="http://schemas.microsoft.com/office/powerpoint/2010/main" val="1443567038"/>
       </p:ext>
     </p:extLst>
   </p:cSld>
@@ -763,7 +763,7 @@
           <a:p>
             <a:fld id="{CFD239F0-43B1-DD42-BACD-13F81CB3B2FE}" type="datetimeFigureOut">
               <a:rPr lang="en-US" smtClean="0"/>
-              <a:t>4/11/24</a:t>
+              <a:t>3/31/26</a:t>
             </a:fld>
             <a:endParaRPr lang="en-US"/>
           </a:p>
@@ -814,7 +814,7 @@
     </p:spTree>
     <p:extLst>
       <p:ext uri="{BB962C8B-B14F-4D97-AF65-F5344CB8AC3E}">
-        <p14:creationId xmlns:p14="http://schemas.microsoft.com/office/powerpoint/2010/main" val="1946043655"/>
+        <p14:creationId xmlns:p14="http://schemas.microsoft.com/office/powerpoint/2010/main" val="3397347454"/>
       </p:ext>
     </p:extLst>
   </p:cSld>
@@ -853,15 +853,15 @@
         </p:nvSpPr>
         <p:spPr>
           <a:xfrm>
-            <a:off x="467916" y="2279653"/>
-            <a:ext cx="5915025" cy="3803649"/>
+            <a:off x="540378" y="1794831"/>
+            <a:ext cx="6831033" cy="2994714"/>
           </a:xfrm>
         </p:spPr>
         <p:txBody>
           <a:bodyPr anchor="b"/>
           <a:lstStyle>
             <a:lvl1pPr>
-              <a:defRPr sz="4500"/>
+              <a:defRPr sz="5197"/>
             </a:lvl1pPr>
           </a:lstStyle>
           <a:p>
@@ -885,8 +885,8 @@
         </p:nvSpPr>
         <p:spPr>
           <a:xfrm>
-            <a:off x="467916" y="6119286"/>
-            <a:ext cx="5915025" cy="2000249"/>
+            <a:off x="540378" y="4817876"/>
+            <a:ext cx="6831033" cy="1574849"/>
           </a:xfrm>
         </p:spPr>
         <p:txBody>
@@ -894,15 +894,15 @@
           <a:lstStyle>
             <a:lvl1pPr marL="0" indent="0">
               <a:buNone/>
-              <a:defRPr sz="1800">
+              <a:defRPr sz="2079">
                 <a:solidFill>
                   <a:schemeClr val="tx1"/>
                 </a:solidFill>
               </a:defRPr>
             </a:lvl1pPr>
-            <a:lvl2pPr marL="342900" indent="0">
-              <a:buNone/>
-              <a:defRPr sz="1500">
+            <a:lvl2pPr marL="395981" indent="0">
+              <a:buNone/>
+              <a:defRPr sz="1732">
                 <a:solidFill>
                   <a:schemeClr val="tx1">
                     <a:tint val="75000"/>
@@ -910,9 +910,9 @@
                 </a:solidFill>
               </a:defRPr>
             </a:lvl2pPr>
-            <a:lvl3pPr marL="685800" indent="0">
-              <a:buNone/>
-              <a:defRPr sz="1350">
+            <a:lvl3pPr marL="791962" indent="0">
+              <a:buNone/>
+              <a:defRPr sz="1559">
                 <a:solidFill>
                   <a:schemeClr val="tx1">
                     <a:tint val="75000"/>
@@ -920,9 +920,9 @@
                 </a:solidFill>
               </a:defRPr>
             </a:lvl3pPr>
-            <a:lvl4pPr marL="1028700" indent="0">
-              <a:buNone/>
-              <a:defRPr sz="1200">
+            <a:lvl4pPr marL="1187943" indent="0">
+              <a:buNone/>
+              <a:defRPr sz="1386">
                 <a:solidFill>
                   <a:schemeClr val="tx1">
                     <a:tint val="75000"/>
@@ -930,9 +930,9 @@
                 </a:solidFill>
               </a:defRPr>
             </a:lvl4pPr>
-            <a:lvl5pPr marL="1371600" indent="0">
-              <a:buNone/>
-              <a:defRPr sz="1200">
+            <a:lvl5pPr marL="1583924" indent="0">
+              <a:buNone/>
+              <a:defRPr sz="1386">
                 <a:solidFill>
                   <a:schemeClr val="tx1">
                     <a:tint val="75000"/>
@@ -940,9 +940,9 @@
                 </a:solidFill>
               </a:defRPr>
             </a:lvl5pPr>
-            <a:lvl6pPr marL="1714500" indent="0">
-              <a:buNone/>
-              <a:defRPr sz="1200">
+            <a:lvl6pPr marL="1979905" indent="0">
+              <a:buNone/>
+              <a:defRPr sz="1386">
                 <a:solidFill>
                   <a:schemeClr val="tx1">
                     <a:tint val="75000"/>
@@ -950,9 +950,9 @@
                 </a:solidFill>
               </a:defRPr>
             </a:lvl6pPr>
-            <a:lvl7pPr marL="2057400" indent="0">
-              <a:buNone/>
-              <a:defRPr sz="1200">
+            <a:lvl7pPr marL="2375886" indent="0">
+              <a:buNone/>
+              <a:defRPr sz="1386">
                 <a:solidFill>
                   <a:schemeClr val="tx1">
                     <a:tint val="75000"/>
@@ -960,9 +960,9 @@
                 </a:solidFill>
               </a:defRPr>
             </a:lvl7pPr>
-            <a:lvl8pPr marL="2400300" indent="0">
-              <a:buNone/>
-              <a:defRPr sz="1200">
+            <a:lvl8pPr marL="2771866" indent="0">
+              <a:buNone/>
+              <a:defRPr sz="1386">
                 <a:solidFill>
                   <a:schemeClr val="tx1">
                     <a:tint val="75000"/>
@@ -970,9 +970,9 @@
                 </a:solidFill>
               </a:defRPr>
             </a:lvl8pPr>
-            <a:lvl9pPr marL="2743200" indent="0">
-              <a:buNone/>
-              <a:defRPr sz="1200">
+            <a:lvl9pPr marL="3167847" indent="0">
+              <a:buNone/>
+              <a:defRPr sz="1386">
                 <a:solidFill>
                   <a:schemeClr val="tx1">
                     <a:tint val="75000"/>
@@ -1007,7 +1007,7 @@
           <a:p>
             <a:fld id="{CFD239F0-43B1-DD42-BACD-13F81CB3B2FE}" type="datetimeFigureOut">
               <a:rPr lang="en-US" smtClean="0"/>
-              <a:t>4/11/24</a:t>
+              <a:t>3/31/26</a:t>
             </a:fld>
             <a:endParaRPr lang="en-US"/>
           </a:p>
@@ -1058,7 +1058,7 @@
     </p:spTree>
     <p:extLst>
       <p:ext uri="{BB962C8B-B14F-4D97-AF65-F5344CB8AC3E}">
-        <p14:creationId xmlns:p14="http://schemas.microsoft.com/office/powerpoint/2010/main" val="3359345639"/>
+        <p14:creationId xmlns:p14="http://schemas.microsoft.com/office/powerpoint/2010/main" val="1019641468"/>
       </p:ext>
     </p:extLst>
   </p:cSld>
@@ -1120,8 +1120,8 @@
         </p:nvSpPr>
         <p:spPr>
           <a:xfrm>
-            <a:off x="471488" y="2434167"/>
-            <a:ext cx="2914650" cy="5801784"/>
+            <a:off x="544503" y="1916484"/>
+            <a:ext cx="3366016" cy="4567898"/>
           </a:xfrm>
         </p:spPr>
         <p:txBody>
@@ -1177,8 +1177,8 @@
         </p:nvSpPr>
         <p:spPr>
           <a:xfrm>
-            <a:off x="3471863" y="2434167"/>
-            <a:ext cx="2914650" cy="5801784"/>
+            <a:off x="4009519" y="1916484"/>
+            <a:ext cx="3366016" cy="4567898"/>
           </a:xfrm>
         </p:spPr>
         <p:txBody>
@@ -1239,7 +1239,7 @@
           <a:p>
             <a:fld id="{CFD239F0-43B1-DD42-BACD-13F81CB3B2FE}" type="datetimeFigureOut">
               <a:rPr lang="en-US" smtClean="0"/>
-              <a:t>4/11/24</a:t>
+              <a:t>3/31/26</a:t>
             </a:fld>
             <a:endParaRPr lang="en-US"/>
           </a:p>
@@ -1290,7 +1290,7 @@
     </p:spTree>
     <p:extLst>
       <p:ext uri="{BB962C8B-B14F-4D97-AF65-F5344CB8AC3E}">
-        <p14:creationId xmlns:p14="http://schemas.microsoft.com/office/powerpoint/2010/main" val="2240325353"/>
+        <p14:creationId xmlns:p14="http://schemas.microsoft.com/office/powerpoint/2010/main" val="1524222704"/>
       </p:ext>
     </p:extLst>
   </p:cSld>
@@ -1329,8 +1329,8 @@
         </p:nvSpPr>
         <p:spPr>
           <a:xfrm>
-            <a:off x="472381" y="486836"/>
-            <a:ext cx="5915025" cy="1767417"/>
+            <a:off x="545534" y="383299"/>
+            <a:ext cx="6831033" cy="1391534"/>
           </a:xfrm>
         </p:spPr>
         <p:txBody>
@@ -1357,8 +1357,8 @@
         </p:nvSpPr>
         <p:spPr>
           <a:xfrm>
-            <a:off x="472381" y="2241551"/>
-            <a:ext cx="2901255" cy="1098549"/>
+            <a:off x="545535" y="1764832"/>
+            <a:ext cx="3350547" cy="864917"/>
           </a:xfrm>
         </p:spPr>
         <p:txBody>
@@ -1366,39 +1366,39 @@
           <a:lstStyle>
             <a:lvl1pPr marL="0" indent="0">
               <a:buNone/>
-              <a:defRPr sz="1800" b="1"/>
+              <a:defRPr sz="2079" b="1"/>
             </a:lvl1pPr>
-            <a:lvl2pPr marL="342900" indent="0">
-              <a:buNone/>
-              <a:defRPr sz="1500" b="1"/>
+            <a:lvl2pPr marL="395981" indent="0">
+              <a:buNone/>
+              <a:defRPr sz="1732" b="1"/>
             </a:lvl2pPr>
-            <a:lvl3pPr marL="685800" indent="0">
-              <a:buNone/>
-              <a:defRPr sz="1350" b="1"/>
+            <a:lvl3pPr marL="791962" indent="0">
+              <a:buNone/>
+              <a:defRPr sz="1559" b="1"/>
             </a:lvl3pPr>
-            <a:lvl4pPr marL="1028700" indent="0">
-              <a:buNone/>
-              <a:defRPr sz="1200" b="1"/>
+            <a:lvl4pPr marL="1187943" indent="0">
+              <a:buNone/>
+              <a:defRPr sz="1386" b="1"/>
             </a:lvl4pPr>
-            <a:lvl5pPr marL="1371600" indent="0">
-              <a:buNone/>
-              <a:defRPr sz="1200" b="1"/>
+            <a:lvl5pPr marL="1583924" indent="0">
+              <a:buNone/>
+              <a:defRPr sz="1386" b="1"/>
             </a:lvl5pPr>
-            <a:lvl6pPr marL="1714500" indent="0">
-              <a:buNone/>
-              <a:defRPr sz="1200" b="1"/>
+            <a:lvl6pPr marL="1979905" indent="0">
+              <a:buNone/>
+              <a:defRPr sz="1386" b="1"/>
             </a:lvl6pPr>
-            <a:lvl7pPr marL="2057400" indent="0">
-              <a:buNone/>
-              <a:defRPr sz="1200" b="1"/>
+            <a:lvl7pPr marL="2375886" indent="0">
+              <a:buNone/>
+              <a:defRPr sz="1386" b="1"/>
             </a:lvl7pPr>
-            <a:lvl8pPr marL="2400300" indent="0">
-              <a:buNone/>
-              <a:defRPr sz="1200" b="1"/>
+            <a:lvl8pPr marL="2771866" indent="0">
+              <a:buNone/>
+              <a:defRPr sz="1386" b="1"/>
             </a:lvl8pPr>
-            <a:lvl9pPr marL="2743200" indent="0">
-              <a:buNone/>
-              <a:defRPr sz="1200" b="1"/>
+            <a:lvl9pPr marL="3167847" indent="0">
+              <a:buNone/>
+              <a:defRPr sz="1386" b="1"/>
             </a:lvl9pPr>
           </a:lstStyle>
           <a:p>
@@ -1422,8 +1422,8 @@
         </p:nvSpPr>
         <p:spPr>
           <a:xfrm>
-            <a:off x="472381" y="3340100"/>
-            <a:ext cx="2901255" cy="4912784"/>
+            <a:off x="545535" y="2629749"/>
+            <a:ext cx="3350547" cy="3867965"/>
           </a:xfrm>
         </p:spPr>
         <p:txBody>
@@ -1479,8 +1479,8 @@
         </p:nvSpPr>
         <p:spPr>
           <a:xfrm>
-            <a:off x="3471863" y="2241551"/>
-            <a:ext cx="2915543" cy="1098549"/>
+            <a:off x="4009520" y="1764832"/>
+            <a:ext cx="3367048" cy="864917"/>
           </a:xfrm>
         </p:spPr>
         <p:txBody>
@@ -1488,39 +1488,39 @@
           <a:lstStyle>
             <a:lvl1pPr marL="0" indent="0">
               <a:buNone/>
-              <a:defRPr sz="1800" b="1"/>
+              <a:defRPr sz="2079" b="1"/>
             </a:lvl1pPr>
-            <a:lvl2pPr marL="342900" indent="0">
-              <a:buNone/>
-              <a:defRPr sz="1500" b="1"/>
+            <a:lvl2pPr marL="395981" indent="0">
+              <a:buNone/>
+              <a:defRPr sz="1732" b="1"/>
             </a:lvl2pPr>
-            <a:lvl3pPr marL="685800" indent="0">
-              <a:buNone/>
-              <a:defRPr sz="1350" b="1"/>
+            <a:lvl3pPr marL="791962" indent="0">
+              <a:buNone/>
+              <a:defRPr sz="1559" b="1"/>
             </a:lvl3pPr>
-            <a:lvl4pPr marL="1028700" indent="0">
-              <a:buNone/>
-              <a:defRPr sz="1200" b="1"/>
+            <a:lvl4pPr marL="1187943" indent="0">
+              <a:buNone/>
+              <a:defRPr sz="1386" b="1"/>
             </a:lvl4pPr>
-            <a:lvl5pPr marL="1371600" indent="0">
-              <a:buNone/>
-              <a:defRPr sz="1200" b="1"/>
+            <a:lvl5pPr marL="1583924" indent="0">
+              <a:buNone/>
+              <a:defRPr sz="1386" b="1"/>
             </a:lvl5pPr>
-            <a:lvl6pPr marL="1714500" indent="0">
-              <a:buNone/>
-              <a:defRPr sz="1200" b="1"/>
+            <a:lvl6pPr marL="1979905" indent="0">
+              <a:buNone/>
+              <a:defRPr sz="1386" b="1"/>
             </a:lvl6pPr>
-            <a:lvl7pPr marL="2057400" indent="0">
-              <a:buNone/>
-              <a:defRPr sz="1200" b="1"/>
+            <a:lvl7pPr marL="2375886" indent="0">
+              <a:buNone/>
+              <a:defRPr sz="1386" b="1"/>
             </a:lvl7pPr>
-            <a:lvl8pPr marL="2400300" indent="0">
-              <a:buNone/>
-              <a:defRPr sz="1200" b="1"/>
+            <a:lvl8pPr marL="2771866" indent="0">
+              <a:buNone/>
+              <a:defRPr sz="1386" b="1"/>
             </a:lvl8pPr>
-            <a:lvl9pPr marL="2743200" indent="0">
-              <a:buNone/>
-              <a:defRPr sz="1200" b="1"/>
+            <a:lvl9pPr marL="3167847" indent="0">
+              <a:buNone/>
+              <a:defRPr sz="1386" b="1"/>
             </a:lvl9pPr>
           </a:lstStyle>
           <a:p>
@@ -1544,8 +1544,8 @@
         </p:nvSpPr>
         <p:spPr>
           <a:xfrm>
-            <a:off x="3471863" y="3340100"/>
-            <a:ext cx="2915543" cy="4912784"/>
+            <a:off x="4009520" y="2629749"/>
+            <a:ext cx="3367048" cy="3867965"/>
           </a:xfrm>
         </p:spPr>
         <p:txBody>
@@ -1606,7 +1606,7 @@
           <a:p>
             <a:fld id="{CFD239F0-43B1-DD42-BACD-13F81CB3B2FE}" type="datetimeFigureOut">
               <a:rPr lang="en-US" smtClean="0"/>
-              <a:t>4/11/24</a:t>
+              <a:t>3/31/26</a:t>
             </a:fld>
             <a:endParaRPr lang="en-US"/>
           </a:p>
@@ -1657,7 +1657,7 @@
     </p:spTree>
     <p:extLst>
       <p:ext uri="{BB962C8B-B14F-4D97-AF65-F5344CB8AC3E}">
-        <p14:creationId xmlns:p14="http://schemas.microsoft.com/office/powerpoint/2010/main" val="1691202924"/>
+        <p14:creationId xmlns:p14="http://schemas.microsoft.com/office/powerpoint/2010/main" val="3213199863"/>
       </p:ext>
     </p:extLst>
   </p:cSld>
@@ -1724,7 +1724,7 @@
           <a:p>
             <a:fld id="{CFD239F0-43B1-DD42-BACD-13F81CB3B2FE}" type="datetimeFigureOut">
               <a:rPr lang="en-US" smtClean="0"/>
-              <a:t>4/11/24</a:t>
+              <a:t>3/31/26</a:t>
             </a:fld>
             <a:endParaRPr lang="en-US"/>
           </a:p>
@@ -1775,7 +1775,7 @@
     </p:spTree>
     <p:extLst>
       <p:ext uri="{BB962C8B-B14F-4D97-AF65-F5344CB8AC3E}">
-        <p14:creationId xmlns:p14="http://schemas.microsoft.com/office/powerpoint/2010/main" val="2071626002"/>
+        <p14:creationId xmlns:p14="http://schemas.microsoft.com/office/powerpoint/2010/main" val="1112495144"/>
       </p:ext>
     </p:extLst>
   </p:cSld>
@@ -1819,7 +1819,7 @@
           <a:p>
             <a:fld id="{CFD239F0-43B1-DD42-BACD-13F81CB3B2FE}" type="datetimeFigureOut">
               <a:rPr lang="en-US" smtClean="0"/>
-              <a:t>4/11/24</a:t>
+              <a:t>3/31/26</a:t>
             </a:fld>
             <a:endParaRPr lang="en-US"/>
           </a:p>
@@ -1870,7 +1870,7 @@
     </p:spTree>
     <p:extLst>
       <p:ext uri="{BB962C8B-B14F-4D97-AF65-F5344CB8AC3E}">
-        <p14:creationId xmlns:p14="http://schemas.microsoft.com/office/powerpoint/2010/main" val="2176756372"/>
+        <p14:creationId xmlns:p14="http://schemas.microsoft.com/office/powerpoint/2010/main" val="3608208018"/>
       </p:ext>
     </p:extLst>
   </p:cSld>
@@ -1909,15 +1909,15 @@
         </p:nvSpPr>
         <p:spPr>
           <a:xfrm>
-            <a:off x="472381" y="609600"/>
-            <a:ext cx="2211884" cy="2133600"/>
+            <a:off x="545534" y="479954"/>
+            <a:ext cx="2554418" cy="1679840"/>
           </a:xfrm>
         </p:spPr>
         <p:txBody>
           <a:bodyPr anchor="b"/>
           <a:lstStyle>
             <a:lvl1pPr>
-              <a:defRPr sz="2400"/>
+              <a:defRPr sz="2772"/>
             </a:lvl1pPr>
           </a:lstStyle>
           <a:p>
@@ -1941,39 +1941,39 @@
         </p:nvSpPr>
         <p:spPr>
           <a:xfrm>
-            <a:off x="2915543" y="1316569"/>
-            <a:ext cx="3471863" cy="6498167"/>
+            <a:off x="3367048" y="1036570"/>
+            <a:ext cx="4009519" cy="5116178"/>
           </a:xfrm>
         </p:spPr>
         <p:txBody>
           <a:bodyPr/>
           <a:lstStyle>
             <a:lvl1pPr>
-              <a:defRPr sz="2400"/>
+              <a:defRPr sz="2772"/>
             </a:lvl1pPr>
             <a:lvl2pPr>
-              <a:defRPr sz="2100"/>
+              <a:defRPr sz="2425"/>
             </a:lvl2pPr>
             <a:lvl3pPr>
-              <a:defRPr sz="1800"/>
+              <a:defRPr sz="2079"/>
             </a:lvl3pPr>
             <a:lvl4pPr>
-              <a:defRPr sz="1500"/>
+              <a:defRPr sz="1732"/>
             </a:lvl4pPr>
             <a:lvl5pPr>
-              <a:defRPr sz="1500"/>
+              <a:defRPr sz="1732"/>
             </a:lvl5pPr>
             <a:lvl6pPr>
-              <a:defRPr sz="1500"/>
+              <a:defRPr sz="1732"/>
             </a:lvl6pPr>
             <a:lvl7pPr>
-              <a:defRPr sz="1500"/>
+              <a:defRPr sz="1732"/>
             </a:lvl7pPr>
             <a:lvl8pPr>
-              <a:defRPr sz="1500"/>
+              <a:defRPr sz="1732"/>
             </a:lvl8pPr>
             <a:lvl9pPr>
-              <a:defRPr sz="1500"/>
+              <a:defRPr sz="1732"/>
             </a:lvl9pPr>
           </a:lstStyle>
           <a:p>
@@ -2026,8 +2026,8 @@
         </p:nvSpPr>
         <p:spPr>
           <a:xfrm>
-            <a:off x="472381" y="2743200"/>
-            <a:ext cx="2211884" cy="5082117"/>
+            <a:off x="545534" y="2159794"/>
+            <a:ext cx="2554418" cy="4001285"/>
           </a:xfrm>
         </p:spPr>
         <p:txBody>
@@ -2035,39 +2035,39 @@
           <a:lstStyle>
             <a:lvl1pPr marL="0" indent="0">
               <a:buNone/>
-              <a:defRPr sz="1200"/>
+              <a:defRPr sz="1386"/>
             </a:lvl1pPr>
-            <a:lvl2pPr marL="342900" indent="0">
-              <a:buNone/>
-              <a:defRPr sz="1050"/>
+            <a:lvl2pPr marL="395981" indent="0">
+              <a:buNone/>
+              <a:defRPr sz="1213"/>
             </a:lvl2pPr>
-            <a:lvl3pPr marL="685800" indent="0">
-              <a:buNone/>
-              <a:defRPr sz="900"/>
+            <a:lvl3pPr marL="791962" indent="0">
+              <a:buNone/>
+              <a:defRPr sz="1039"/>
             </a:lvl3pPr>
-            <a:lvl4pPr marL="1028700" indent="0">
-              <a:buNone/>
-              <a:defRPr sz="750"/>
+            <a:lvl4pPr marL="1187943" indent="0">
+              <a:buNone/>
+              <a:defRPr sz="866"/>
             </a:lvl4pPr>
-            <a:lvl5pPr marL="1371600" indent="0">
-              <a:buNone/>
-              <a:defRPr sz="750"/>
+            <a:lvl5pPr marL="1583924" indent="0">
+              <a:buNone/>
+              <a:defRPr sz="866"/>
             </a:lvl5pPr>
-            <a:lvl6pPr marL="1714500" indent="0">
-              <a:buNone/>
-              <a:defRPr sz="750"/>
+            <a:lvl6pPr marL="1979905" indent="0">
+              <a:buNone/>
+              <a:defRPr sz="866"/>
             </a:lvl6pPr>
-            <a:lvl7pPr marL="2057400" indent="0">
-              <a:buNone/>
-              <a:defRPr sz="750"/>
+            <a:lvl7pPr marL="2375886" indent="0">
+              <a:buNone/>
+              <a:defRPr sz="866"/>
             </a:lvl7pPr>
-            <a:lvl8pPr marL="2400300" indent="0">
-              <a:buNone/>
-              <a:defRPr sz="750"/>
+            <a:lvl8pPr marL="2771866" indent="0">
+              <a:buNone/>
+              <a:defRPr sz="866"/>
             </a:lvl8pPr>
-            <a:lvl9pPr marL="2743200" indent="0">
-              <a:buNone/>
-              <a:defRPr sz="750"/>
+            <a:lvl9pPr marL="3167847" indent="0">
+              <a:buNone/>
+              <a:defRPr sz="866"/>
             </a:lvl9pPr>
           </a:lstStyle>
           <a:p>
@@ -2096,7 +2096,7 @@
           <a:p>
             <a:fld id="{CFD239F0-43B1-DD42-BACD-13F81CB3B2FE}" type="datetimeFigureOut">
               <a:rPr lang="en-US" smtClean="0"/>
-              <a:t>4/11/24</a:t>
+              <a:t>3/31/26</a:t>
             </a:fld>
             <a:endParaRPr lang="en-US"/>
           </a:p>
@@ -2147,7 +2147,7 @@
     </p:spTree>
     <p:extLst>
       <p:ext uri="{BB962C8B-B14F-4D97-AF65-F5344CB8AC3E}">
-        <p14:creationId xmlns:p14="http://schemas.microsoft.com/office/powerpoint/2010/main" val="4041398427"/>
+        <p14:creationId xmlns:p14="http://schemas.microsoft.com/office/powerpoint/2010/main" val="3853420089"/>
       </p:ext>
     </p:extLst>
   </p:cSld>
@@ -2186,15 +2186,15 @@
         </p:nvSpPr>
         <p:spPr>
           <a:xfrm>
-            <a:off x="472381" y="609600"/>
-            <a:ext cx="2211884" cy="2133600"/>
+            <a:off x="545534" y="479954"/>
+            <a:ext cx="2554418" cy="1679840"/>
           </a:xfrm>
         </p:spPr>
         <p:txBody>
           <a:bodyPr anchor="b"/>
           <a:lstStyle>
             <a:lvl1pPr>
-              <a:defRPr sz="2400"/>
+              <a:defRPr sz="2772"/>
             </a:lvl1pPr>
           </a:lstStyle>
           <a:p>
@@ -2218,8 +2218,8 @@
         </p:nvSpPr>
         <p:spPr>
           <a:xfrm>
-            <a:off x="2915543" y="1316569"/>
-            <a:ext cx="3471863" cy="6498167"/>
+            <a:off x="3367048" y="1036570"/>
+            <a:ext cx="4009519" cy="5116178"/>
           </a:xfrm>
         </p:spPr>
         <p:txBody>
@@ -2227,39 +2227,39 @@
           <a:lstStyle>
             <a:lvl1pPr marL="0" indent="0">
               <a:buNone/>
-              <a:defRPr sz="2400"/>
+              <a:defRPr sz="2772"/>
             </a:lvl1pPr>
-            <a:lvl2pPr marL="342900" indent="0">
-              <a:buNone/>
-              <a:defRPr sz="2100"/>
+            <a:lvl2pPr marL="395981" indent="0">
+              <a:buNone/>
+              <a:defRPr sz="2425"/>
             </a:lvl2pPr>
-            <a:lvl3pPr marL="685800" indent="0">
-              <a:buNone/>
-              <a:defRPr sz="1800"/>
+            <a:lvl3pPr marL="791962" indent="0">
+              <a:buNone/>
+              <a:defRPr sz="2079"/>
             </a:lvl3pPr>
-            <a:lvl4pPr marL="1028700" indent="0">
-              <a:buNone/>
-              <a:defRPr sz="1500"/>
+            <a:lvl4pPr marL="1187943" indent="0">
+              <a:buNone/>
+              <a:defRPr sz="1732"/>
             </a:lvl4pPr>
-            <a:lvl5pPr marL="1371600" indent="0">
-              <a:buNone/>
-              <a:defRPr sz="1500"/>
+            <a:lvl5pPr marL="1583924" indent="0">
+              <a:buNone/>
+              <a:defRPr sz="1732"/>
             </a:lvl5pPr>
-            <a:lvl6pPr marL="1714500" indent="0">
-              <a:buNone/>
-              <a:defRPr sz="1500"/>
+            <a:lvl6pPr marL="1979905" indent="0">
+              <a:buNone/>
+              <a:defRPr sz="1732"/>
             </a:lvl6pPr>
-            <a:lvl7pPr marL="2057400" indent="0">
-              <a:buNone/>
-              <a:defRPr sz="1500"/>
+            <a:lvl7pPr marL="2375886" indent="0">
+              <a:buNone/>
+              <a:defRPr sz="1732"/>
             </a:lvl7pPr>
-            <a:lvl8pPr marL="2400300" indent="0">
-              <a:buNone/>
-              <a:defRPr sz="1500"/>
+            <a:lvl8pPr marL="2771866" indent="0">
+              <a:buNone/>
+              <a:defRPr sz="1732"/>
             </a:lvl8pPr>
-            <a:lvl9pPr marL="2743200" indent="0">
-              <a:buNone/>
-              <a:defRPr sz="1500"/>
+            <a:lvl9pPr marL="3167847" indent="0">
+              <a:buNone/>
+              <a:defRPr sz="1732"/>
             </a:lvl9pPr>
           </a:lstStyle>
           <a:p>
@@ -2283,8 +2283,8 @@
         </p:nvSpPr>
         <p:spPr>
           <a:xfrm>
-            <a:off x="472381" y="2743200"/>
-            <a:ext cx="2211884" cy="5082117"/>
+            <a:off x="545534" y="2159794"/>
+            <a:ext cx="2554418" cy="4001285"/>
           </a:xfrm>
         </p:spPr>
         <p:txBody>
@@ -2292,39 +2292,39 @@
           <a:lstStyle>
             <a:lvl1pPr marL="0" indent="0">
               <a:buNone/>
-              <a:defRPr sz="1200"/>
+              <a:defRPr sz="1386"/>
             </a:lvl1pPr>
-            <a:lvl2pPr marL="342900" indent="0">
-              <a:buNone/>
-              <a:defRPr sz="1050"/>
+            <a:lvl2pPr marL="395981" indent="0">
+              <a:buNone/>
+              <a:defRPr sz="1213"/>
             </a:lvl2pPr>
-            <a:lvl3pPr marL="685800" indent="0">
-              <a:buNone/>
-              <a:defRPr sz="900"/>
+            <a:lvl3pPr marL="791962" indent="0">
+              <a:buNone/>
+              <a:defRPr sz="1039"/>
             </a:lvl3pPr>
-            <a:lvl4pPr marL="1028700" indent="0">
-              <a:buNone/>
-              <a:defRPr sz="750"/>
+            <a:lvl4pPr marL="1187943" indent="0">
+              <a:buNone/>
+              <a:defRPr sz="866"/>
             </a:lvl4pPr>
-            <a:lvl5pPr marL="1371600" indent="0">
-              <a:buNone/>
-              <a:defRPr sz="750"/>
+            <a:lvl5pPr marL="1583924" indent="0">
+              <a:buNone/>
+              <a:defRPr sz="866"/>
             </a:lvl5pPr>
-            <a:lvl6pPr marL="1714500" indent="0">
-              <a:buNone/>
-              <a:defRPr sz="750"/>
+            <a:lvl6pPr marL="1979905" indent="0">
+              <a:buNone/>
+              <a:defRPr sz="866"/>
             </a:lvl6pPr>
-            <a:lvl7pPr marL="2057400" indent="0">
-              <a:buNone/>
-              <a:defRPr sz="750"/>
+            <a:lvl7pPr marL="2375886" indent="0">
+              <a:buNone/>
+              <a:defRPr sz="866"/>
             </a:lvl7pPr>
-            <a:lvl8pPr marL="2400300" indent="0">
-              <a:buNone/>
-              <a:defRPr sz="750"/>
+            <a:lvl8pPr marL="2771866" indent="0">
+              <a:buNone/>
+              <a:defRPr sz="866"/>
             </a:lvl8pPr>
-            <a:lvl9pPr marL="2743200" indent="0">
-              <a:buNone/>
-              <a:defRPr sz="750"/>
+            <a:lvl9pPr marL="3167847" indent="0">
+              <a:buNone/>
+              <a:defRPr sz="866"/>
             </a:lvl9pPr>
           </a:lstStyle>
           <a:p>
@@ -2353,7 +2353,7 @@
           <a:p>
             <a:fld id="{CFD239F0-43B1-DD42-BACD-13F81CB3B2FE}" type="datetimeFigureOut">
               <a:rPr lang="en-US" smtClean="0"/>
-              <a:t>4/11/24</a:t>
+              <a:t>3/31/26</a:t>
             </a:fld>
             <a:endParaRPr lang="en-US"/>
           </a:p>
@@ -2404,7 +2404,7 @@
     </p:spTree>
     <p:extLst>
       <p:ext uri="{BB962C8B-B14F-4D97-AF65-F5344CB8AC3E}">
-        <p14:creationId xmlns:p14="http://schemas.microsoft.com/office/powerpoint/2010/main" val="700773030"/>
+        <p14:creationId xmlns:p14="http://schemas.microsoft.com/office/powerpoint/2010/main" val="2392122210"/>
       </p:ext>
     </p:extLst>
   </p:cSld>
@@ -2448,8 +2448,8 @@
         </p:nvSpPr>
         <p:spPr>
           <a:xfrm>
-            <a:off x="471488" y="486836"/>
-            <a:ext cx="5915025" cy="1767417"/>
+            <a:off x="544503" y="383299"/>
+            <a:ext cx="6831033" cy="1391534"/>
           </a:xfrm>
           <a:prstGeom prst="rect">
             <a:avLst/>
@@ -2481,8 +2481,8 @@
         </p:nvSpPr>
         <p:spPr>
           <a:xfrm>
-            <a:off x="471488" y="2434167"/>
-            <a:ext cx="5915025" cy="5801784"/>
+            <a:off x="544503" y="1916484"/>
+            <a:ext cx="6831033" cy="4567898"/>
           </a:xfrm>
           <a:prstGeom prst="rect">
             <a:avLst/>
@@ -2543,8 +2543,8 @@
         </p:nvSpPr>
         <p:spPr>
           <a:xfrm>
-            <a:off x="471488" y="8475136"/>
-            <a:ext cx="1543050" cy="486833"/>
+            <a:off x="544502" y="6672698"/>
+            <a:ext cx="1782009" cy="383297"/>
           </a:xfrm>
           <a:prstGeom prst="rect">
             <a:avLst/>
@@ -2554,7 +2554,7 @@
           <a:bodyPr vert="horz" lIns="91440" tIns="45720" rIns="91440" bIns="45720" rtlCol="0" anchor="ctr"/>
           <a:lstStyle>
             <a:lvl1pPr algn="l">
-              <a:defRPr sz="900">
+              <a:defRPr sz="1039">
                 <a:solidFill>
                   <a:schemeClr val="tx1">
                     <a:tint val="75000"/>
@@ -2566,7 +2566,7 @@
           <a:p>
             <a:fld id="{CFD239F0-43B1-DD42-BACD-13F81CB3B2FE}" type="datetimeFigureOut">
               <a:rPr lang="en-US" smtClean="0"/>
-              <a:t>4/11/24</a:t>
+              <a:t>3/31/26</a:t>
             </a:fld>
             <a:endParaRPr lang="en-US"/>
           </a:p>
@@ -2584,8 +2584,8 @@
         </p:nvSpPr>
         <p:spPr>
           <a:xfrm>
-            <a:off x="2271713" y="8475136"/>
-            <a:ext cx="2314575" cy="486833"/>
+            <a:off x="2623513" y="6672698"/>
+            <a:ext cx="2673013" cy="383297"/>
           </a:xfrm>
           <a:prstGeom prst="rect">
             <a:avLst/>
@@ -2595,7 +2595,7 @@
           <a:bodyPr vert="horz" lIns="91440" tIns="45720" rIns="91440" bIns="45720" rtlCol="0" anchor="ctr"/>
           <a:lstStyle>
             <a:lvl1pPr algn="ctr">
-              <a:defRPr sz="900">
+              <a:defRPr sz="1039">
                 <a:solidFill>
                   <a:schemeClr val="tx1">
                     <a:tint val="75000"/>
@@ -2621,8 +2621,8 @@
         </p:nvSpPr>
         <p:spPr>
           <a:xfrm>
-            <a:off x="4843463" y="8475136"/>
-            <a:ext cx="1543050" cy="486833"/>
+            <a:off x="5593527" y="6672698"/>
+            <a:ext cx="1782009" cy="383297"/>
           </a:xfrm>
           <a:prstGeom prst="rect">
             <a:avLst/>
@@ -2632,7 +2632,7 @@
           <a:bodyPr vert="horz" lIns="91440" tIns="45720" rIns="91440" bIns="45720" rtlCol="0" anchor="ctr"/>
           <a:lstStyle>
             <a:lvl1pPr algn="r">
-              <a:defRPr sz="900">
+              <a:defRPr sz="1039">
                 <a:solidFill>
                   <a:schemeClr val="tx1">
                     <a:tint val="75000"/>
@@ -2653,27 +2653,27 @@
     </p:spTree>
     <p:extLst>
       <p:ext uri="{BB962C8B-B14F-4D97-AF65-F5344CB8AC3E}">
-        <p14:creationId xmlns:p14="http://schemas.microsoft.com/office/powerpoint/2010/main" val="3368725738"/>
+        <p14:creationId xmlns:p14="http://schemas.microsoft.com/office/powerpoint/2010/main" val="1700899601"/>
       </p:ext>
     </p:extLst>
   </p:cSld>
   <p:clrMap bg1="lt1" tx1="dk1" bg2="lt2" tx2="dk2" accent1="accent1" accent2="accent2" accent3="accent3" accent4="accent4" accent5="accent5" accent6="accent6" hlink="hlink" folHlink="folHlink"/>
   <p:sldLayoutIdLst>
-    <p:sldLayoutId id="2147483661" r:id="rId1"/>
-    <p:sldLayoutId id="2147483662" r:id="rId2"/>
-    <p:sldLayoutId id="2147483663" r:id="rId3"/>
-    <p:sldLayoutId id="2147483664" r:id="rId4"/>
-    <p:sldLayoutId id="2147483665" r:id="rId5"/>
-    <p:sldLayoutId id="2147483666" r:id="rId6"/>
-    <p:sldLayoutId id="2147483667" r:id="rId7"/>
-    <p:sldLayoutId id="2147483668" r:id="rId8"/>
-    <p:sldLayoutId id="2147483669" r:id="rId9"/>
-    <p:sldLayoutId id="2147483670" r:id="rId10"/>
-    <p:sldLayoutId id="2147483671" r:id="rId11"/>
+    <p:sldLayoutId id="2147483709" r:id="rId1"/>
+    <p:sldLayoutId id="2147483710" r:id="rId2"/>
+    <p:sldLayoutId id="2147483711" r:id="rId3"/>
+    <p:sldLayoutId id="2147483712" r:id="rId4"/>
+    <p:sldLayoutId id="2147483713" r:id="rId5"/>
+    <p:sldLayoutId id="2147483714" r:id="rId6"/>
+    <p:sldLayoutId id="2147483715" r:id="rId7"/>
+    <p:sldLayoutId id="2147483716" r:id="rId8"/>
+    <p:sldLayoutId id="2147483717" r:id="rId9"/>
+    <p:sldLayoutId id="2147483718" r:id="rId10"/>
+    <p:sldLayoutId id="2147483719" r:id="rId11"/>
   </p:sldLayoutIdLst>
   <p:txStyles>
     <p:titleStyle>
-      <a:lvl1pPr algn="l" defTabSz="685800" rtl="0" eaLnBrk="1" latinLnBrk="0" hangingPunct="1">
+      <a:lvl1pPr algn="l" defTabSz="791962" rtl="0" eaLnBrk="1" latinLnBrk="0" hangingPunct="1">
         <a:lnSpc>
           <a:spcPct val="90000"/>
         </a:lnSpc>
@@ -2681,7 +2681,7 @@
           <a:spcPct val="0"/>
         </a:spcBef>
         <a:buNone/>
-        <a:defRPr sz="3300" kern="1200">
+        <a:defRPr sz="3811" kern="1200">
           <a:solidFill>
             <a:schemeClr val="tx1"/>
           </a:solidFill>
@@ -2692,16 +2692,16 @@
       </a:lvl1pPr>
     </p:titleStyle>
     <p:bodyStyle>
-      <a:lvl1pPr marL="171450" indent="-171450" algn="l" defTabSz="685800" rtl="0" eaLnBrk="1" latinLnBrk="0" hangingPunct="1">
+      <a:lvl1pPr marL="197990" indent="-197990" algn="l" defTabSz="791962" rtl="0" eaLnBrk="1" latinLnBrk="0" hangingPunct="1">
         <a:lnSpc>
           <a:spcPct val="90000"/>
         </a:lnSpc>
         <a:spcBef>
-          <a:spcPts val="750"/>
+          <a:spcPts val="866"/>
         </a:spcBef>
         <a:buFont typeface="Arial" panose="020B0604020202020204" pitchFamily="34" charset="0"/>
         <a:buChar char="•"/>
-        <a:defRPr sz="2100" kern="1200">
+        <a:defRPr sz="2425" kern="1200">
           <a:solidFill>
             <a:schemeClr val="tx1"/>
           </a:solidFill>
@@ -2710,16 +2710,16 @@
           <a:cs typeface="+mn-cs"/>
         </a:defRPr>
       </a:lvl1pPr>
-      <a:lvl2pPr marL="514350" indent="-171450" algn="l" defTabSz="685800" rtl="0" eaLnBrk="1" latinLnBrk="0" hangingPunct="1">
+      <a:lvl2pPr marL="593971" indent="-197990" algn="l" defTabSz="791962" rtl="0" eaLnBrk="1" latinLnBrk="0" hangingPunct="1">
         <a:lnSpc>
           <a:spcPct val="90000"/>
         </a:lnSpc>
         <a:spcBef>
-          <a:spcPts val="375"/>
+          <a:spcPts val="433"/>
         </a:spcBef>
         <a:buFont typeface="Arial" panose="020B0604020202020204" pitchFamily="34" charset="0"/>
         <a:buChar char="•"/>
-        <a:defRPr sz="1800" kern="1200">
+        <a:defRPr sz="2079" kern="1200">
           <a:solidFill>
             <a:schemeClr val="tx1"/>
           </a:solidFill>
@@ -2728,16 +2728,16 @@
           <a:cs typeface="+mn-cs"/>
         </a:defRPr>
       </a:lvl2pPr>
-      <a:lvl3pPr marL="857250" indent="-171450" algn="l" defTabSz="685800" rtl="0" eaLnBrk="1" latinLnBrk="0" hangingPunct="1">
+      <a:lvl3pPr marL="989952" indent="-197990" algn="l" defTabSz="791962" rtl="0" eaLnBrk="1" latinLnBrk="0" hangingPunct="1">
         <a:lnSpc>
           <a:spcPct val="90000"/>
         </a:lnSpc>
         <a:spcBef>
-          <a:spcPts val="375"/>
+          <a:spcPts val="433"/>
         </a:spcBef>
         <a:buFont typeface="Arial" panose="020B0604020202020204" pitchFamily="34" charset="0"/>
         <a:buChar char="•"/>
-        <a:defRPr sz="1500" kern="1200">
+        <a:defRPr sz="1732" kern="1200">
           <a:solidFill>
             <a:schemeClr val="tx1"/>
           </a:solidFill>
@@ -2746,16 +2746,16 @@
           <a:cs typeface="+mn-cs"/>
         </a:defRPr>
       </a:lvl3pPr>
-      <a:lvl4pPr marL="1200150" indent="-171450" algn="l" defTabSz="685800" rtl="0" eaLnBrk="1" latinLnBrk="0" hangingPunct="1">
+      <a:lvl4pPr marL="1385933" indent="-197990" algn="l" defTabSz="791962" rtl="0" eaLnBrk="1" latinLnBrk="0" hangingPunct="1">
         <a:lnSpc>
           <a:spcPct val="90000"/>
         </a:lnSpc>
         <a:spcBef>
-          <a:spcPts val="375"/>
+          <a:spcPts val="433"/>
         </a:spcBef>
         <a:buFont typeface="Arial" panose="020B0604020202020204" pitchFamily="34" charset="0"/>
         <a:buChar char="•"/>
-        <a:defRPr sz="1350" kern="1200">
+        <a:defRPr sz="1559" kern="1200">
           <a:solidFill>
             <a:schemeClr val="tx1"/>
           </a:solidFill>
@@ -2764,16 +2764,16 @@
           <a:cs typeface="+mn-cs"/>
         </a:defRPr>
       </a:lvl4pPr>
-      <a:lvl5pPr marL="1543050" indent="-171450" algn="l" defTabSz="685800" rtl="0" eaLnBrk="1" latinLnBrk="0" hangingPunct="1">
+      <a:lvl5pPr marL="1781914" indent="-197990" algn="l" defTabSz="791962" rtl="0" eaLnBrk="1" latinLnBrk="0" hangingPunct="1">
         <a:lnSpc>
           <a:spcPct val="90000"/>
         </a:lnSpc>
         <a:spcBef>
-          <a:spcPts val="375"/>
+          <a:spcPts val="433"/>
         </a:spcBef>
         <a:buFont typeface="Arial" panose="020B0604020202020204" pitchFamily="34" charset="0"/>
         <a:buChar char="•"/>
-        <a:defRPr sz="1350" kern="1200">
+        <a:defRPr sz="1559" kern="1200">
           <a:solidFill>
             <a:schemeClr val="tx1"/>
           </a:solidFill>
@@ -2782,16 +2782,16 @@
           <a:cs typeface="+mn-cs"/>
         </a:defRPr>
       </a:lvl5pPr>
-      <a:lvl6pPr marL="1885950" indent="-171450" algn="l" defTabSz="685800" rtl="0" eaLnBrk="1" latinLnBrk="0" hangingPunct="1">
+      <a:lvl6pPr marL="2177895" indent="-197990" algn="l" defTabSz="791962" rtl="0" eaLnBrk="1" latinLnBrk="0" hangingPunct="1">
         <a:lnSpc>
           <a:spcPct val="90000"/>
         </a:lnSpc>
         <a:spcBef>
-          <a:spcPts val="375"/>
+          <a:spcPts val="433"/>
         </a:spcBef>
         <a:buFont typeface="Arial" panose="020B0604020202020204" pitchFamily="34" charset="0"/>
         <a:buChar char="•"/>
-        <a:defRPr sz="1350" kern="1200">
+        <a:defRPr sz="1559" kern="1200">
           <a:solidFill>
             <a:schemeClr val="tx1"/>
           </a:solidFill>
@@ -2800,16 +2800,16 @@
           <a:cs typeface="+mn-cs"/>
         </a:defRPr>
       </a:lvl6pPr>
-      <a:lvl7pPr marL="2228850" indent="-171450" algn="l" defTabSz="685800" rtl="0" eaLnBrk="1" latinLnBrk="0" hangingPunct="1">
+      <a:lvl7pPr marL="2573876" indent="-197990" algn="l" defTabSz="791962" rtl="0" eaLnBrk="1" latinLnBrk="0" hangingPunct="1">
         <a:lnSpc>
           <a:spcPct val="90000"/>
         </a:lnSpc>
         <a:spcBef>
-          <a:spcPts val="375"/>
+          <a:spcPts val="433"/>
         </a:spcBef>
         <a:buFont typeface="Arial" panose="020B0604020202020204" pitchFamily="34" charset="0"/>
         <a:buChar char="•"/>
-        <a:defRPr sz="1350" kern="1200">
+        <a:defRPr sz="1559" kern="1200">
           <a:solidFill>
             <a:schemeClr val="tx1"/>
           </a:solidFill>
@@ -2818,16 +2818,16 @@
           <a:cs typeface="+mn-cs"/>
         </a:defRPr>
       </a:lvl7pPr>
-      <a:lvl8pPr marL="2571750" indent="-171450" algn="l" defTabSz="685800" rtl="0" eaLnBrk="1" latinLnBrk="0" hangingPunct="1">
+      <a:lvl8pPr marL="2969857" indent="-197990" algn="l" defTabSz="791962" rtl="0" eaLnBrk="1" latinLnBrk="0" hangingPunct="1">
         <a:lnSpc>
           <a:spcPct val="90000"/>
         </a:lnSpc>
         <a:spcBef>
-          <a:spcPts val="375"/>
+          <a:spcPts val="433"/>
         </a:spcBef>
         <a:buFont typeface="Arial" panose="020B0604020202020204" pitchFamily="34" charset="0"/>
         <a:buChar char="•"/>
-        <a:defRPr sz="1350" kern="1200">
+        <a:defRPr sz="1559" kern="1200">
           <a:solidFill>
             <a:schemeClr val="tx1"/>
           </a:solidFill>
@@ -2836,16 +2836,16 @@
           <a:cs typeface="+mn-cs"/>
         </a:defRPr>
       </a:lvl8pPr>
-      <a:lvl9pPr marL="2914650" indent="-171450" algn="l" defTabSz="685800" rtl="0" eaLnBrk="1" latinLnBrk="0" hangingPunct="1">
+      <a:lvl9pPr marL="3365838" indent="-197990" algn="l" defTabSz="791962" rtl="0" eaLnBrk="1" latinLnBrk="0" hangingPunct="1">
         <a:lnSpc>
           <a:spcPct val="90000"/>
         </a:lnSpc>
         <a:spcBef>
-          <a:spcPts val="375"/>
+          <a:spcPts val="433"/>
         </a:spcBef>
         <a:buFont typeface="Arial" panose="020B0604020202020204" pitchFamily="34" charset="0"/>
         <a:buChar char="•"/>
-        <a:defRPr sz="1350" kern="1200">
+        <a:defRPr sz="1559" kern="1200">
           <a:solidFill>
             <a:schemeClr val="tx1"/>
           </a:solidFill>
@@ -2859,8 +2859,8 @@
       <a:defPPr>
         <a:defRPr lang="en-US"/>
       </a:defPPr>
-      <a:lvl1pPr marL="0" algn="l" defTabSz="685800" rtl="0" eaLnBrk="1" latinLnBrk="0" hangingPunct="1">
-        <a:defRPr sz="1350" kern="1200">
+      <a:lvl1pPr marL="0" algn="l" defTabSz="791962" rtl="0" eaLnBrk="1" latinLnBrk="0" hangingPunct="1">
+        <a:defRPr sz="1559" kern="1200">
           <a:solidFill>
             <a:schemeClr val="tx1"/>
           </a:solidFill>
@@ -2869,8 +2869,8 @@
           <a:cs typeface="+mn-cs"/>
         </a:defRPr>
       </a:lvl1pPr>
-      <a:lvl2pPr marL="342900" algn="l" defTabSz="685800" rtl="0" eaLnBrk="1" latinLnBrk="0" hangingPunct="1">
-        <a:defRPr sz="1350" kern="1200">
+      <a:lvl2pPr marL="395981" algn="l" defTabSz="791962" rtl="0" eaLnBrk="1" latinLnBrk="0" hangingPunct="1">
+        <a:defRPr sz="1559" kern="1200">
           <a:solidFill>
             <a:schemeClr val="tx1"/>
           </a:solidFill>
@@ -2879,8 +2879,8 @@
           <a:cs typeface="+mn-cs"/>
         </a:defRPr>
       </a:lvl2pPr>
-      <a:lvl3pPr marL="685800" algn="l" defTabSz="685800" rtl="0" eaLnBrk="1" latinLnBrk="0" hangingPunct="1">
-        <a:defRPr sz="1350" kern="1200">
+      <a:lvl3pPr marL="791962" algn="l" defTabSz="791962" rtl="0" eaLnBrk="1" latinLnBrk="0" hangingPunct="1">
+        <a:defRPr sz="1559" kern="1200">
           <a:solidFill>
             <a:schemeClr val="tx1"/>
           </a:solidFill>
@@ -2889,8 +2889,8 @@
           <a:cs typeface="+mn-cs"/>
         </a:defRPr>
       </a:lvl3pPr>
-      <a:lvl4pPr marL="1028700" algn="l" defTabSz="685800" rtl="0" eaLnBrk="1" latinLnBrk="0" hangingPunct="1">
-        <a:defRPr sz="1350" kern="1200">
+      <a:lvl4pPr marL="1187943" algn="l" defTabSz="791962" rtl="0" eaLnBrk="1" latinLnBrk="0" hangingPunct="1">
+        <a:defRPr sz="1559" kern="1200">
           <a:solidFill>
             <a:schemeClr val="tx1"/>
           </a:solidFill>
@@ -2899,8 +2899,8 @@
           <a:cs typeface="+mn-cs"/>
         </a:defRPr>
       </a:lvl4pPr>
-      <a:lvl5pPr marL="1371600" algn="l" defTabSz="685800" rtl="0" eaLnBrk="1" latinLnBrk="0" hangingPunct="1">
-        <a:defRPr sz="1350" kern="1200">
+      <a:lvl5pPr marL="1583924" algn="l" defTabSz="791962" rtl="0" eaLnBrk="1" latinLnBrk="0" hangingPunct="1">
+        <a:defRPr sz="1559" kern="1200">
           <a:solidFill>
             <a:schemeClr val="tx1"/>
           </a:solidFill>
@@ -2909,8 +2909,8 @@
           <a:cs typeface="+mn-cs"/>
         </a:defRPr>
       </a:lvl5pPr>
-      <a:lvl6pPr marL="1714500" algn="l" defTabSz="685800" rtl="0" eaLnBrk="1" latinLnBrk="0" hangingPunct="1">
-        <a:defRPr sz="1350" kern="1200">
+      <a:lvl6pPr marL="1979905" algn="l" defTabSz="791962" rtl="0" eaLnBrk="1" latinLnBrk="0" hangingPunct="1">
+        <a:defRPr sz="1559" kern="1200">
           <a:solidFill>
             <a:schemeClr val="tx1"/>
           </a:solidFill>
@@ -2919,8 +2919,8 @@
           <a:cs typeface="+mn-cs"/>
         </a:defRPr>
       </a:lvl6pPr>
-      <a:lvl7pPr marL="2057400" algn="l" defTabSz="685800" rtl="0" eaLnBrk="1" latinLnBrk="0" hangingPunct="1">
-        <a:defRPr sz="1350" kern="1200">
+      <a:lvl7pPr marL="2375886" algn="l" defTabSz="791962" rtl="0" eaLnBrk="1" latinLnBrk="0" hangingPunct="1">
+        <a:defRPr sz="1559" kern="1200">
           <a:solidFill>
             <a:schemeClr val="tx1"/>
           </a:solidFill>
@@ -2929,8 +2929,8 @@
           <a:cs typeface="+mn-cs"/>
         </a:defRPr>
       </a:lvl7pPr>
-      <a:lvl8pPr marL="2400300" algn="l" defTabSz="685800" rtl="0" eaLnBrk="1" latinLnBrk="0" hangingPunct="1">
-        <a:defRPr sz="1350" kern="1200">
+      <a:lvl8pPr marL="2771866" algn="l" defTabSz="791962" rtl="0" eaLnBrk="1" latinLnBrk="0" hangingPunct="1">
+        <a:defRPr sz="1559" kern="1200">
           <a:solidFill>
             <a:schemeClr val="tx1"/>
           </a:solidFill>
@@ -2939,8 +2939,8 @@
           <a:cs typeface="+mn-cs"/>
         </a:defRPr>
       </a:lvl8pPr>
-      <a:lvl9pPr marL="2743200" algn="l" defTabSz="685800" rtl="0" eaLnBrk="1" latinLnBrk="0" hangingPunct="1">
-        <a:defRPr sz="1350" kern="1200">
+      <a:lvl9pPr marL="3167847" algn="l" defTabSz="791962" rtl="0" eaLnBrk="1" latinLnBrk="0" hangingPunct="1">
+        <a:defRPr sz="1559" kern="1200">
           <a:solidFill>
             <a:schemeClr val="tx1"/>
           </a:solidFill>
@@ -3000,7 +3000,7 @@
         </p:blipFill>
         <p:spPr bwMode="auto">
           <a:xfrm>
-            <a:off x="96989" y="1612961"/>
+            <a:off x="59833" y="321014"/>
             <a:ext cx="6656959" cy="6415028"/>
           </a:xfrm>
           <a:prstGeom prst="rect">
@@ -3032,7 +3032,7 @@
         </p:nvSpPr>
         <p:spPr>
           <a:xfrm>
-            <a:off x="2211255" y="1909864"/>
+            <a:off x="2174099" y="617921"/>
             <a:ext cx="93785" cy="1271081"/>
           </a:xfrm>
           <a:prstGeom prst="rect">
@@ -3084,7 +3084,7 @@
         </p:nvCxnSpPr>
         <p:spPr>
           <a:xfrm flipV="1">
-            <a:off x="2258148" y="1624403"/>
+            <a:off x="2220988" y="332460"/>
             <a:ext cx="0" cy="263767"/>
           </a:xfrm>
           <a:prstGeom prst="straightConnector1">
@@ -3126,7 +3126,7 @@
         </p:nvSpPr>
         <p:spPr>
           <a:xfrm>
-            <a:off x="1762848" y="1347404"/>
+            <a:off x="1725688" y="55461"/>
             <a:ext cx="1084384" cy="276999"/>
           </a:xfrm>
           <a:prstGeom prst="rect">
@@ -3174,7 +3174,7 @@
         </p:nvSpPr>
         <p:spPr>
           <a:xfrm rot="5400000">
-            <a:off x="3894058" y="4252420"/>
+            <a:off x="3856898" y="2960477"/>
             <a:ext cx="89560" cy="2068541"/>
           </a:xfrm>
           <a:prstGeom prst="rect">
@@ -3228,7 +3228,7 @@
         </p:nvCxnSpPr>
         <p:spPr>
           <a:xfrm>
-            <a:off x="4973109" y="5293403"/>
+            <a:off x="4935949" y="4001456"/>
             <a:ext cx="241976" cy="0"/>
           </a:xfrm>
           <a:prstGeom prst="straightConnector1">
@@ -3270,7 +3270,7 @@
         </p:nvSpPr>
         <p:spPr>
           <a:xfrm rot="5400000">
-            <a:off x="4777918" y="5144515"/>
+            <a:off x="4740762" y="3852572"/>
             <a:ext cx="1139015" cy="276999"/>
           </a:xfrm>
           <a:prstGeom prst="rect">
@@ -3318,7 +3318,7 @@
         </p:nvSpPr>
         <p:spPr>
           <a:xfrm>
-            <a:off x="1169401" y="2776103"/>
+            <a:off x="1132245" y="1484160"/>
             <a:ext cx="1166327" cy="261257"/>
           </a:xfrm>
           <a:prstGeom prst="rect">
@@ -3371,7 +3371,7 @@
         </p:nvCxnSpPr>
         <p:spPr>
           <a:xfrm>
-            <a:off x="2367532" y="2900020"/>
+            <a:off x="2330372" y="1608073"/>
             <a:ext cx="317240" cy="0"/>
           </a:xfrm>
           <a:prstGeom prst="straightConnector1">
@@ -3413,7 +3413,7 @@
         </p:nvSpPr>
         <p:spPr>
           <a:xfrm>
-            <a:off x="2634029" y="2760362"/>
+            <a:off x="2596869" y="1468419"/>
             <a:ext cx="1164956" cy="276999"/>
           </a:xfrm>
           <a:prstGeom prst="rect">
@@ -3461,7 +3461,7 @@
         </p:nvSpPr>
         <p:spPr>
           <a:xfrm>
-            <a:off x="4364118" y="2128605"/>
+            <a:off x="4326958" y="836658"/>
             <a:ext cx="643638" cy="369332"/>
           </a:xfrm>
           <a:prstGeom prst="rect">
@@ -3504,7 +3504,7 @@
         </p:nvCxnSpPr>
         <p:spPr>
           <a:xfrm>
-            <a:off x="3453902" y="2128787"/>
+            <a:off x="3416746" y="836840"/>
             <a:ext cx="940869" cy="0"/>
           </a:xfrm>
           <a:prstGeom prst="straightConnector1">
@@ -3546,7 +3546,7 @@
         </p:nvCxnSpPr>
         <p:spPr>
           <a:xfrm>
-            <a:off x="3471551" y="2308274"/>
+            <a:off x="3434395" y="1016327"/>
             <a:ext cx="940869" cy="0"/>
           </a:xfrm>
           <a:prstGeom prst="straightConnector1">
@@ -3588,7 +3588,7 @@
         </p:nvCxnSpPr>
         <p:spPr>
           <a:xfrm>
-            <a:off x="3460320" y="2495782"/>
+            <a:off x="3423164" y="1203835"/>
             <a:ext cx="940869" cy="0"/>
           </a:xfrm>
           <a:prstGeom prst="straightConnector1">
@@ -3632,7 +3632,7 @@
         </p:nvCxnSpPr>
         <p:spPr>
           <a:xfrm>
-            <a:off x="3959953" y="7117744"/>
+            <a:off x="3922793" y="5825797"/>
             <a:ext cx="0" cy="747422"/>
           </a:xfrm>
           <a:prstGeom prst="straightConnector1">
@@ -3674,7 +3674,7 @@
         </p:nvSpPr>
         <p:spPr>
           <a:xfrm>
-            <a:off x="3691328" y="7861371"/>
+            <a:off x="3654168" y="6569428"/>
             <a:ext cx="554872" cy="276999"/>
           </a:xfrm>
           <a:prstGeom prst="rect">
@@ -3722,7 +3722,7 @@
         </p:nvSpPr>
         <p:spPr>
           <a:xfrm rot="16200000">
-            <a:off x="2999603" y="3771335"/>
+            <a:off x="2962447" y="2479392"/>
             <a:ext cx="1166327" cy="197793"/>
           </a:xfrm>
           <a:prstGeom prst="rect">
@@ -3778,7 +3778,7 @@
         </p:nvCxnSpPr>
         <p:spPr>
           <a:xfrm flipV="1">
-            <a:off x="3582767" y="3005677"/>
+            <a:off x="3545607" y="1713734"/>
             <a:ext cx="0" cy="281391"/>
           </a:xfrm>
           <a:prstGeom prst="straightConnector1">
@@ -3820,8 +3820,8 @@
         </p:nvSpPr>
         <p:spPr>
           <a:xfrm>
-            <a:off x="4535673" y="2436640"/>
-            <a:ext cx="1271695" cy="369332"/>
+            <a:off x="4383103" y="1144693"/>
+            <a:ext cx="1372748" cy="369332"/>
           </a:xfrm>
           <a:prstGeom prst="rect">
             <a:avLst/>
@@ -3835,7 +3835,7 @@
           <a:p>
             <a:r>
               <a:rPr lang="en-US" dirty="0" err="1"/>
-              <a:t>legend_gap</a:t>
+              <a:t>legend_vgap</a:t>
             </a:r>
             <a:endParaRPr lang="en-US" dirty="0"/>
           </a:p>
@@ -3857,7 +3857,7 @@
         </p:nvCxnSpPr>
         <p:spPr>
           <a:xfrm flipH="1">
-            <a:off x="5757475" y="2484307"/>
+            <a:off x="5720319" y="1192364"/>
             <a:ext cx="251503" cy="130421"/>
           </a:xfrm>
           <a:prstGeom prst="straightConnector1">
@@ -3901,7 +3901,7 @@
         </p:nvCxnSpPr>
         <p:spPr>
           <a:xfrm flipH="1" flipV="1">
-            <a:off x="5757475" y="2614728"/>
+            <a:off x="5720319" y="1322785"/>
             <a:ext cx="251503" cy="509385"/>
           </a:xfrm>
           <a:prstGeom prst="straightConnector1">
@@ -3943,7 +3943,7 @@
         </p:nvSpPr>
         <p:spPr>
           <a:xfrm>
-            <a:off x="5941710" y="1831799"/>
+            <a:off x="5904550" y="539856"/>
             <a:ext cx="666780" cy="143123"/>
           </a:xfrm>
           <a:prstGeom prst="rect">
@@ -3998,7 +3998,7 @@
         </p:nvSpPr>
         <p:spPr>
           <a:xfrm>
-            <a:off x="4572890" y="1703954"/>
+            <a:off x="4535730" y="412007"/>
             <a:ext cx="1393010" cy="369332"/>
           </a:xfrm>
           <a:prstGeom prst="rect">
@@ -4041,7 +4041,7 @@
         </p:nvSpPr>
         <p:spPr>
           <a:xfrm>
-            <a:off x="4962054" y="3664945"/>
+            <a:off x="4924894" y="2373002"/>
             <a:ext cx="1046924" cy="143123"/>
           </a:xfrm>
           <a:prstGeom prst="rect">
@@ -4094,7 +4094,7 @@
         </p:nvSpPr>
         <p:spPr>
           <a:xfrm>
-            <a:off x="4936182" y="3389746"/>
+            <a:off x="4899026" y="2097803"/>
             <a:ext cx="1138581" cy="307777"/>
           </a:xfrm>
           <a:prstGeom prst="rect">
@@ -4137,7 +4137,7 @@
         </p:nvSpPr>
         <p:spPr>
           <a:xfrm>
-            <a:off x="793495" y="6628652"/>
+            <a:off x="756335" y="5336709"/>
             <a:ext cx="254000" cy="832831"/>
           </a:xfrm>
           <a:prstGeom prst="rect">
@@ -4192,7 +4192,7 @@
         </p:nvCxnSpPr>
         <p:spPr>
           <a:xfrm>
-            <a:off x="920495" y="7461483"/>
+            <a:off x="883335" y="6169536"/>
             <a:ext cx="0" cy="696070"/>
           </a:xfrm>
           <a:prstGeom prst="straightConnector1">
@@ -4234,7 +4234,7 @@
         </p:nvSpPr>
         <p:spPr>
           <a:xfrm>
-            <a:off x="125156" y="8153114"/>
+            <a:off x="87996" y="6861171"/>
             <a:ext cx="1582484" cy="276999"/>
           </a:xfrm>
           <a:prstGeom prst="rect">
@@ -4284,7 +4284,7 @@
         </p:nvSpPr>
         <p:spPr>
           <a:xfrm>
-            <a:off x="338078" y="4297434"/>
+            <a:off x="300922" y="3005487"/>
             <a:ext cx="709417" cy="755374"/>
           </a:xfrm>
           <a:prstGeom prst="rect">
@@ -4340,7 +4340,7 @@
         </p:nvCxnSpPr>
         <p:spPr>
           <a:xfrm>
-            <a:off x="692787" y="5052808"/>
+            <a:off x="655627" y="3760861"/>
             <a:ext cx="0" cy="2740526"/>
           </a:xfrm>
           <a:prstGeom prst="straightConnector1">
@@ -4382,7 +4382,7 @@
         </p:nvSpPr>
         <p:spPr>
           <a:xfrm>
-            <a:off x="0" y="7716814"/>
+            <a:off x="-37160" y="6424871"/>
             <a:ext cx="1596912" cy="276999"/>
           </a:xfrm>
           <a:prstGeom prst="rect">
@@ -4437,7 +4437,7 @@
         </p:nvSpPr>
         <p:spPr>
           <a:xfrm>
-            <a:off x="1894523" y="7247165"/>
+            <a:off x="1857363" y="5955222"/>
             <a:ext cx="771590" cy="546169"/>
           </a:xfrm>
           <a:prstGeom prst="rect">
@@ -4488,14 +4488,15 @@
             </a:extLst>
           </p:cNvPr>
           <p:cNvCxnSpPr>
+            <a:cxnSpLocks/>
             <a:stCxn id="56" idx="3"/>
           </p:cNvCxnSpPr>
           <p:nvPr/>
         </p:nvCxnSpPr>
         <p:spPr>
           <a:xfrm>
-            <a:off x="2666113" y="7520250"/>
-            <a:ext cx="2249196" cy="4501"/>
+            <a:off x="2628953" y="6228307"/>
+            <a:ext cx="2019824" cy="0"/>
           </a:xfrm>
           <a:prstGeom prst="straightConnector1">
             <a:avLst/>
@@ -4538,7 +4539,7 @@
         </p:nvSpPr>
         <p:spPr>
           <a:xfrm>
-            <a:off x="4931278" y="7352896"/>
+            <a:off x="4672175" y="6060953"/>
             <a:ext cx="1596912" cy="276999"/>
           </a:xfrm>
           <a:prstGeom prst="rect">
@@ -4616,7 +4617,7 @@
         </p:nvCxnSpPr>
         <p:spPr>
           <a:xfrm>
-            <a:off x="4962054" y="3736507"/>
+            <a:off x="4924894" y="2444560"/>
             <a:ext cx="1046924" cy="0"/>
           </a:xfrm>
           <a:prstGeom prst="straightConnector1">
@@ -4662,7 +4663,7 @@
         </p:nvCxnSpPr>
         <p:spPr>
           <a:xfrm>
-            <a:off x="1752565" y="2776103"/>
+            <a:off x="1715405" y="1484160"/>
             <a:ext cx="0" cy="261257"/>
           </a:xfrm>
           <a:prstGeom prst="straightConnector1">
@@ -4691,6 +4692,643 @@
           </a:fontRef>
         </p:style>
       </p:cxnSp>
+      <p:sp>
+        <p:nvSpPr>
+          <p:cNvPr id="2" name="Rectangle 1">
+            <a:extLst>
+              <a:ext uri="{FF2B5EF4-FFF2-40B4-BE49-F238E27FC236}">
+                <a16:creationId xmlns:a16="http://schemas.microsoft.com/office/drawing/2014/main" id="{60FCB051-C6D6-F444-ACD1-D1928E9CBBDA}"/>
+              </a:ext>
+            </a:extLst>
+          </p:cNvPr>
+          <p:cNvSpPr/>
+          <p:nvPr/>
+        </p:nvSpPr>
+        <p:spPr>
+          <a:xfrm>
+            <a:off x="5971818" y="682979"/>
+            <a:ext cx="744974" cy="4350660"/>
+          </a:xfrm>
+          <a:prstGeom prst="rect">
+            <a:avLst/>
+          </a:prstGeom>
+          <a:noFill/>
+          <a:ln>
+            <a:solidFill>
+              <a:srgbClr val="FF0000"/>
+            </a:solidFill>
+            <a:prstDash val="dash"/>
+          </a:ln>
+        </p:spPr>
+        <p:style>
+          <a:lnRef idx="2">
+            <a:schemeClr val="accent1">
+              <a:shade val="50000"/>
+            </a:schemeClr>
+          </a:lnRef>
+          <a:fillRef idx="1">
+            <a:schemeClr val="accent1"/>
+          </a:fillRef>
+          <a:effectRef idx="0">
+            <a:schemeClr val="accent1"/>
+          </a:effectRef>
+          <a:fontRef idx="minor">
+            <a:schemeClr val="lt1"/>
+          </a:fontRef>
+        </p:style>
+        <p:txBody>
+          <a:bodyPr rtlCol="0" anchor="ctr"/>
+          <a:lstStyle/>
+          <a:p>
+            <a:pPr algn="ctr"/>
+            <a:endParaRPr lang="en-US"/>
+          </a:p>
+        </p:txBody>
+      </p:sp>
+      <p:sp>
+        <p:nvSpPr>
+          <p:cNvPr id="42" name="Rectangle 41">
+            <a:extLst>
+              <a:ext uri="{FF2B5EF4-FFF2-40B4-BE49-F238E27FC236}">
+                <a16:creationId xmlns:a16="http://schemas.microsoft.com/office/drawing/2014/main" id="{AA935D3E-107D-1A4D-9CA7-D3A06EABB974}"/>
+              </a:ext>
+            </a:extLst>
+          </p:cNvPr>
+          <p:cNvSpPr/>
+          <p:nvPr/>
+        </p:nvSpPr>
+        <p:spPr>
+          <a:xfrm>
+            <a:off x="7107500" y="682979"/>
+            <a:ext cx="744974" cy="4350660"/>
+          </a:xfrm>
+          <a:prstGeom prst="rect">
+            <a:avLst/>
+          </a:prstGeom>
+          <a:noFill/>
+          <a:ln>
+            <a:solidFill>
+              <a:srgbClr val="FF0000"/>
+            </a:solidFill>
+            <a:prstDash val="dash"/>
+          </a:ln>
+        </p:spPr>
+        <p:style>
+          <a:lnRef idx="2">
+            <a:schemeClr val="accent1">
+              <a:shade val="50000"/>
+            </a:schemeClr>
+          </a:lnRef>
+          <a:fillRef idx="1">
+            <a:schemeClr val="accent1"/>
+          </a:fillRef>
+          <a:effectRef idx="0">
+            <a:schemeClr val="accent1"/>
+          </a:effectRef>
+          <a:fontRef idx="minor">
+            <a:schemeClr val="lt1"/>
+          </a:fontRef>
+        </p:style>
+        <p:txBody>
+          <a:bodyPr rtlCol="0" anchor="ctr"/>
+          <a:lstStyle/>
+          <a:p>
+            <a:pPr algn="ctr"/>
+            <a:endParaRPr lang="en-US"/>
+          </a:p>
+        </p:txBody>
+      </p:sp>
+      <p:sp>
+        <p:nvSpPr>
+          <p:cNvPr id="3" name="TextBox 2">
+            <a:extLst>
+              <a:ext uri="{FF2B5EF4-FFF2-40B4-BE49-F238E27FC236}">
+                <a16:creationId xmlns:a16="http://schemas.microsoft.com/office/drawing/2014/main" id="{0FE983BD-1935-524B-87F8-589AA22EC767}"/>
+              </a:ext>
+            </a:extLst>
+          </p:cNvPr>
+          <p:cNvSpPr txBox="1"/>
+          <p:nvPr/>
+        </p:nvSpPr>
+        <p:spPr>
+          <a:xfrm>
+            <a:off x="5882155" y="5105876"/>
+            <a:ext cx="896783" cy="461665"/>
+          </a:xfrm>
+          <a:prstGeom prst="rect">
+            <a:avLst/>
+          </a:prstGeom>
+          <a:noFill/>
+        </p:spPr>
+        <p:txBody>
+          <a:bodyPr wrap="square" rtlCol="0">
+            <a:spAutoFit/>
+          </a:bodyPr>
+          <a:lstStyle/>
+          <a:p>
+            <a:pPr algn="ctr"/>
+            <a:r>
+              <a:rPr lang="en-US" sz="1200" dirty="0">
+                <a:latin typeface="Arial" panose="020B0604020202020204" pitchFamily="34" charset="0"/>
+                <a:cs typeface="Arial" panose="020B0604020202020204" pitchFamily="34" charset="0"/>
+              </a:rPr>
+              <a:t>1</a:t>
+            </a:r>
+            <a:r>
+              <a:rPr lang="en-US" sz="1200" baseline="30000" dirty="0">
+                <a:latin typeface="Arial" panose="020B0604020202020204" pitchFamily="34" charset="0"/>
+                <a:cs typeface="Arial" panose="020B0604020202020204" pitchFamily="34" charset="0"/>
+              </a:rPr>
+              <a:t>st</a:t>
+            </a:r>
+            <a:r>
+              <a:rPr lang="en-US" sz="1200" dirty="0">
+                <a:latin typeface="Arial" panose="020B0604020202020204" pitchFamily="34" charset="0"/>
+                <a:cs typeface="Arial" panose="020B0604020202020204" pitchFamily="34" charset="0"/>
+              </a:rPr>
+              <a:t> column of legend</a:t>
+            </a:r>
+          </a:p>
+        </p:txBody>
+      </p:sp>
+      <p:sp>
+        <p:nvSpPr>
+          <p:cNvPr id="44" name="TextBox 43">
+            <a:extLst>
+              <a:ext uri="{FF2B5EF4-FFF2-40B4-BE49-F238E27FC236}">
+                <a16:creationId xmlns:a16="http://schemas.microsoft.com/office/drawing/2014/main" id="{E11B23FD-71D0-9C43-93BF-39E76C4B8764}"/>
+              </a:ext>
+            </a:extLst>
+          </p:cNvPr>
+          <p:cNvSpPr txBox="1"/>
+          <p:nvPr/>
+        </p:nvSpPr>
+        <p:spPr>
+          <a:xfrm>
+            <a:off x="6977848" y="5105876"/>
+            <a:ext cx="927472" cy="461665"/>
+          </a:xfrm>
+          <a:prstGeom prst="rect">
+            <a:avLst/>
+          </a:prstGeom>
+          <a:noFill/>
+        </p:spPr>
+        <p:txBody>
+          <a:bodyPr wrap="square" rtlCol="0">
+            <a:spAutoFit/>
+          </a:bodyPr>
+          <a:lstStyle/>
+          <a:p>
+            <a:pPr algn="ctr"/>
+            <a:r>
+              <a:rPr lang="en-US" sz="1200" dirty="0">
+                <a:latin typeface="Arial" panose="020B0604020202020204" pitchFamily="34" charset="0"/>
+                <a:cs typeface="Arial" panose="020B0604020202020204" pitchFamily="34" charset="0"/>
+              </a:rPr>
+              <a:t>2</a:t>
+            </a:r>
+            <a:r>
+              <a:rPr lang="en-US" sz="1200" baseline="30000" dirty="0">
+                <a:latin typeface="Arial" panose="020B0604020202020204" pitchFamily="34" charset="0"/>
+                <a:cs typeface="Arial" panose="020B0604020202020204" pitchFamily="34" charset="0"/>
+              </a:rPr>
+              <a:t>nd</a:t>
+            </a:r>
+            <a:r>
+              <a:rPr lang="en-US" sz="1200" dirty="0">
+                <a:latin typeface="Arial" panose="020B0604020202020204" pitchFamily="34" charset="0"/>
+                <a:cs typeface="Arial" panose="020B0604020202020204" pitchFamily="34" charset="0"/>
+              </a:rPr>
+              <a:t> column of legend</a:t>
+            </a:r>
+          </a:p>
+        </p:txBody>
+      </p:sp>
+      <p:cxnSp>
+        <p:nvCxnSpPr>
+          <p:cNvPr id="45" name="Straight Arrow Connector 44">
+            <a:extLst>
+              <a:ext uri="{FF2B5EF4-FFF2-40B4-BE49-F238E27FC236}">
+                <a16:creationId xmlns:a16="http://schemas.microsoft.com/office/drawing/2014/main" id="{01320CFF-2697-9E41-BBEF-60716F602A2D}"/>
+              </a:ext>
+            </a:extLst>
+          </p:cNvPr>
+          <p:cNvCxnSpPr>
+            <a:cxnSpLocks/>
+          </p:cNvCxnSpPr>
+          <p:nvPr/>
+        </p:nvCxnSpPr>
+        <p:spPr>
+          <a:xfrm>
+            <a:off x="6716792" y="4274840"/>
+            <a:ext cx="390708" cy="0"/>
+          </a:xfrm>
+          <a:prstGeom prst="straightConnector1">
+            <a:avLst/>
+          </a:prstGeom>
+          <a:ln>
+            <a:solidFill>
+              <a:schemeClr val="tx1"/>
+            </a:solidFill>
+            <a:headEnd type="triangle"/>
+            <a:tailEnd type="triangle"/>
+          </a:ln>
+        </p:spPr>
+        <p:style>
+          <a:lnRef idx="1">
+            <a:schemeClr val="accent1"/>
+          </a:lnRef>
+          <a:fillRef idx="0">
+            <a:schemeClr val="accent1"/>
+          </a:fillRef>
+          <a:effectRef idx="0">
+            <a:schemeClr val="accent1"/>
+          </a:effectRef>
+          <a:fontRef idx="minor">
+            <a:schemeClr val="tx1"/>
+          </a:fontRef>
+        </p:style>
+      </p:cxnSp>
+      <p:cxnSp>
+        <p:nvCxnSpPr>
+          <p:cNvPr id="9" name="Straight Arrow Connector 8">
+            <a:extLst>
+              <a:ext uri="{FF2B5EF4-FFF2-40B4-BE49-F238E27FC236}">
+                <a16:creationId xmlns:a16="http://schemas.microsoft.com/office/drawing/2014/main" id="{6088712F-F0FE-314E-BD60-122E4A0ABF04}"/>
+              </a:ext>
+            </a:extLst>
+          </p:cNvPr>
+          <p:cNvCxnSpPr/>
+          <p:nvPr/>
+        </p:nvCxnSpPr>
+        <p:spPr>
+          <a:xfrm>
+            <a:off x="6906827" y="4376691"/>
+            <a:ext cx="0" cy="1367161"/>
+          </a:xfrm>
+          <a:prstGeom prst="straightConnector1">
+            <a:avLst/>
+          </a:prstGeom>
+          <a:ln>
+            <a:solidFill>
+              <a:schemeClr val="tx1"/>
+            </a:solidFill>
+            <a:tailEnd type="triangle"/>
+          </a:ln>
+        </p:spPr>
+        <p:style>
+          <a:lnRef idx="1">
+            <a:schemeClr val="accent1"/>
+          </a:lnRef>
+          <a:fillRef idx="0">
+            <a:schemeClr val="accent1"/>
+          </a:fillRef>
+          <a:effectRef idx="0">
+            <a:schemeClr val="accent1"/>
+          </a:effectRef>
+          <a:fontRef idx="minor">
+            <a:schemeClr val="tx1"/>
+          </a:fontRef>
+        </p:style>
+      </p:cxnSp>
+      <p:sp>
+        <p:nvSpPr>
+          <p:cNvPr id="50" name="Rectangle 49">
+            <a:extLst>
+              <a:ext uri="{FF2B5EF4-FFF2-40B4-BE49-F238E27FC236}">
+                <a16:creationId xmlns:a16="http://schemas.microsoft.com/office/drawing/2014/main" id="{6BEEE17A-1634-F645-987F-147BCB34BEB8}"/>
+              </a:ext>
+            </a:extLst>
+          </p:cNvPr>
+          <p:cNvSpPr/>
+          <p:nvPr/>
+        </p:nvSpPr>
+        <p:spPr>
+          <a:xfrm>
+            <a:off x="6302024" y="5710785"/>
+            <a:ext cx="1218603" cy="307777"/>
+          </a:xfrm>
+          <a:prstGeom prst="rect">
+            <a:avLst/>
+          </a:prstGeom>
+        </p:spPr>
+        <p:txBody>
+          <a:bodyPr wrap="none">
+            <a:spAutoFit/>
+          </a:bodyPr>
+          <a:lstStyle/>
+          <a:p>
+            <a:r>
+              <a:rPr lang="en-US" sz="1400" dirty="0" err="1">
+                <a:latin typeface="Arial" panose="020B0604020202020204" pitchFamily="34" charset="0"/>
+                <a:cs typeface="Arial" panose="020B0604020202020204" pitchFamily="34" charset="0"/>
+              </a:rPr>
+              <a:t>legend_hgap</a:t>
+            </a:r>
+            <a:endParaRPr lang="en-US" sz="1400" dirty="0">
+              <a:latin typeface="Arial" panose="020B0604020202020204" pitchFamily="34" charset="0"/>
+              <a:cs typeface="Arial" panose="020B0604020202020204" pitchFamily="34" charset="0"/>
+            </a:endParaRPr>
+          </a:p>
+        </p:txBody>
+      </p:sp>
+      <p:cxnSp>
+        <p:nvCxnSpPr>
+          <p:cNvPr id="52" name="Straight Arrow Connector 51">
+            <a:extLst>
+              <a:ext uri="{FF2B5EF4-FFF2-40B4-BE49-F238E27FC236}">
+                <a16:creationId xmlns:a16="http://schemas.microsoft.com/office/drawing/2014/main" id="{59FDFB7E-F339-6145-BB79-0F1316FDD556}"/>
+              </a:ext>
+            </a:extLst>
+          </p:cNvPr>
+          <p:cNvCxnSpPr>
+            <a:cxnSpLocks/>
+          </p:cNvCxnSpPr>
+          <p:nvPr/>
+        </p:nvCxnSpPr>
+        <p:spPr>
+          <a:xfrm>
+            <a:off x="5971818" y="391534"/>
+            <a:ext cx="1880656" cy="0"/>
+          </a:xfrm>
+          <a:prstGeom prst="straightConnector1">
+            <a:avLst/>
+          </a:prstGeom>
+          <a:ln>
+            <a:solidFill>
+              <a:schemeClr val="tx1"/>
+            </a:solidFill>
+            <a:headEnd type="triangle"/>
+            <a:tailEnd type="triangle"/>
+          </a:ln>
+        </p:spPr>
+        <p:style>
+          <a:lnRef idx="1">
+            <a:schemeClr val="accent1"/>
+          </a:lnRef>
+          <a:fillRef idx="0">
+            <a:schemeClr val="accent1"/>
+          </a:fillRef>
+          <a:effectRef idx="0">
+            <a:schemeClr val="accent1"/>
+          </a:effectRef>
+          <a:fontRef idx="minor">
+            <a:schemeClr val="tx1"/>
+          </a:fontRef>
+        </p:style>
+      </p:cxnSp>
+      <p:sp>
+        <p:nvSpPr>
+          <p:cNvPr id="53" name="Rectangle 52">
+            <a:extLst>
+              <a:ext uri="{FF2B5EF4-FFF2-40B4-BE49-F238E27FC236}">
+                <a16:creationId xmlns:a16="http://schemas.microsoft.com/office/drawing/2014/main" id="{7D756BB7-8D2B-D446-8940-8C597FB934FB}"/>
+              </a:ext>
+            </a:extLst>
+          </p:cNvPr>
+          <p:cNvSpPr/>
+          <p:nvPr/>
+        </p:nvSpPr>
+        <p:spPr>
+          <a:xfrm>
+            <a:off x="6233774" y="83757"/>
+            <a:ext cx="1239442" cy="307777"/>
+          </a:xfrm>
+          <a:prstGeom prst="rect">
+            <a:avLst/>
+          </a:prstGeom>
+        </p:spPr>
+        <p:txBody>
+          <a:bodyPr wrap="none">
+            <a:spAutoFit/>
+          </a:bodyPr>
+          <a:lstStyle/>
+          <a:p>
+            <a:r>
+              <a:rPr lang="en-US" sz="1400" dirty="0" err="1">
+                <a:latin typeface="Arial" panose="020B0604020202020204" pitchFamily="34" charset="0"/>
+                <a:cs typeface="Arial" panose="020B0604020202020204" pitchFamily="34" charset="0"/>
+              </a:rPr>
+              <a:t>legend_width</a:t>
+            </a:r>
+            <a:endParaRPr lang="en-US" sz="1400" dirty="0">
+              <a:latin typeface="Arial" panose="020B0604020202020204" pitchFamily="34" charset="0"/>
+              <a:cs typeface="Arial" panose="020B0604020202020204" pitchFamily="34" charset="0"/>
+            </a:endParaRPr>
+          </a:p>
+        </p:txBody>
+      </p:sp>
+      <p:sp>
+        <p:nvSpPr>
+          <p:cNvPr id="21" name="TextBox 20">
+            <a:extLst>
+              <a:ext uri="{FF2B5EF4-FFF2-40B4-BE49-F238E27FC236}">
+                <a16:creationId xmlns:a16="http://schemas.microsoft.com/office/drawing/2014/main" id="{F83CD0D1-CDFD-7C4E-B39D-9A40E0359421}"/>
+              </a:ext>
+            </a:extLst>
+          </p:cNvPr>
+          <p:cNvSpPr txBox="1"/>
+          <p:nvPr/>
+        </p:nvSpPr>
+        <p:spPr>
+          <a:xfrm>
+            <a:off x="7210751" y="1911592"/>
+            <a:ext cx="461665" cy="1371204"/>
+          </a:xfrm>
+          <a:prstGeom prst="rect">
+            <a:avLst/>
+          </a:prstGeom>
+          <a:noFill/>
+        </p:spPr>
+        <p:txBody>
+          <a:bodyPr vert="vert270" wrap="square" rtlCol="0">
+            <a:spAutoFit/>
+          </a:bodyPr>
+          <a:lstStyle/>
+          <a:p>
+            <a:r>
+              <a:rPr lang="en-US" dirty="0" err="1"/>
+              <a:t>legend_order</a:t>
+            </a:r>
+            <a:endParaRPr lang="en-US" dirty="0"/>
+          </a:p>
+        </p:txBody>
+      </p:sp>
+      <p:cxnSp>
+        <p:nvCxnSpPr>
+          <p:cNvPr id="55" name="Straight Arrow Connector 54">
+            <a:extLst>
+              <a:ext uri="{FF2B5EF4-FFF2-40B4-BE49-F238E27FC236}">
+                <a16:creationId xmlns:a16="http://schemas.microsoft.com/office/drawing/2014/main" id="{D2ECC6E9-BF50-B24B-B8AB-BE260590EE94}"/>
+              </a:ext>
+            </a:extLst>
+          </p:cNvPr>
+          <p:cNvCxnSpPr>
+            <a:cxnSpLocks/>
+          </p:cNvCxnSpPr>
+          <p:nvPr/>
+        </p:nvCxnSpPr>
+        <p:spPr>
+          <a:xfrm>
+            <a:off x="5846070" y="4376691"/>
+            <a:ext cx="0" cy="461639"/>
+          </a:xfrm>
+          <a:prstGeom prst="straightConnector1">
+            <a:avLst/>
+          </a:prstGeom>
+          <a:ln>
+            <a:solidFill>
+              <a:schemeClr val="tx1"/>
+            </a:solidFill>
+            <a:headEnd type="triangle"/>
+            <a:tailEnd type="triangle"/>
+          </a:ln>
+        </p:spPr>
+        <p:style>
+          <a:lnRef idx="1">
+            <a:schemeClr val="accent1"/>
+          </a:lnRef>
+          <a:fillRef idx="0">
+            <a:schemeClr val="accent1"/>
+          </a:fillRef>
+          <a:effectRef idx="0">
+            <a:schemeClr val="accent1"/>
+          </a:effectRef>
+          <a:fontRef idx="minor">
+            <a:schemeClr val="tx1"/>
+          </a:fontRef>
+        </p:style>
+      </p:cxnSp>
+      <p:sp>
+        <p:nvSpPr>
+          <p:cNvPr id="58" name="Rectangle 57">
+            <a:extLst>
+              <a:ext uri="{FF2B5EF4-FFF2-40B4-BE49-F238E27FC236}">
+                <a16:creationId xmlns:a16="http://schemas.microsoft.com/office/drawing/2014/main" id="{A64CBA1F-9C65-2A43-BEFB-7BD406375EA4}"/>
+              </a:ext>
+            </a:extLst>
+          </p:cNvPr>
+          <p:cNvSpPr/>
+          <p:nvPr/>
+        </p:nvSpPr>
+        <p:spPr>
+          <a:xfrm>
+            <a:off x="4919230" y="4465076"/>
+            <a:ext cx="988643" cy="276999"/>
+          </a:xfrm>
+          <a:prstGeom prst="rect">
+            <a:avLst/>
+          </a:prstGeom>
+        </p:spPr>
+        <p:txBody>
+          <a:bodyPr wrap="square">
+            <a:spAutoFit/>
+          </a:bodyPr>
+          <a:lstStyle/>
+          <a:p>
+            <a:r>
+              <a:rPr lang="en-US" sz="1200" dirty="0" err="1">
+                <a:latin typeface="Arial" panose="020B0604020202020204" pitchFamily="34" charset="0"/>
+                <a:cs typeface="Arial" panose="020B0604020202020204" pitchFamily="34" charset="0"/>
+              </a:rPr>
+              <a:t>cbar_height</a:t>
+            </a:r>
+            <a:endParaRPr lang="en-US" sz="1200" dirty="0">
+              <a:latin typeface="Arial" panose="020B0604020202020204" pitchFamily="34" charset="0"/>
+              <a:cs typeface="Arial" panose="020B0604020202020204" pitchFamily="34" charset="0"/>
+            </a:endParaRPr>
+          </a:p>
+        </p:txBody>
+      </p:sp>
+      <p:cxnSp>
+        <p:nvCxnSpPr>
+          <p:cNvPr id="60" name="Straight Arrow Connector 59">
+            <a:extLst>
+              <a:ext uri="{FF2B5EF4-FFF2-40B4-BE49-F238E27FC236}">
+                <a16:creationId xmlns:a16="http://schemas.microsoft.com/office/drawing/2014/main" id="{DE0F94FA-A1B6-9F48-A92B-095D892A9783}"/>
+              </a:ext>
+            </a:extLst>
+          </p:cNvPr>
+          <p:cNvCxnSpPr>
+            <a:cxnSpLocks/>
+          </p:cNvCxnSpPr>
+          <p:nvPr/>
+        </p:nvCxnSpPr>
+        <p:spPr>
+          <a:xfrm>
+            <a:off x="5897436" y="3160453"/>
+            <a:ext cx="0" cy="461639"/>
+          </a:xfrm>
+          <a:prstGeom prst="straightConnector1">
+            <a:avLst/>
+          </a:prstGeom>
+          <a:ln>
+            <a:solidFill>
+              <a:schemeClr val="tx1"/>
+            </a:solidFill>
+            <a:headEnd type="triangle"/>
+            <a:tailEnd type="triangle"/>
+          </a:ln>
+        </p:spPr>
+        <p:style>
+          <a:lnRef idx="1">
+            <a:schemeClr val="accent1"/>
+          </a:lnRef>
+          <a:fillRef idx="0">
+            <a:schemeClr val="accent1"/>
+          </a:fillRef>
+          <a:effectRef idx="0">
+            <a:schemeClr val="accent1"/>
+          </a:effectRef>
+          <a:fontRef idx="minor">
+            <a:schemeClr val="tx1"/>
+          </a:fontRef>
+        </p:style>
+      </p:cxnSp>
+      <p:sp>
+        <p:nvSpPr>
+          <p:cNvPr id="61" name="Rectangle 60">
+            <a:extLst>
+              <a:ext uri="{FF2B5EF4-FFF2-40B4-BE49-F238E27FC236}">
+                <a16:creationId xmlns:a16="http://schemas.microsoft.com/office/drawing/2014/main" id="{0536B961-58CF-8248-938C-C624ED9F6934}"/>
+              </a:ext>
+            </a:extLst>
+          </p:cNvPr>
+          <p:cNvSpPr/>
+          <p:nvPr/>
+        </p:nvSpPr>
+        <p:spPr>
+          <a:xfrm>
+            <a:off x="4357533" y="3168382"/>
+            <a:ext cx="1555895" cy="276999"/>
+          </a:xfrm>
+          <a:prstGeom prst="rect">
+            <a:avLst/>
+          </a:prstGeom>
+        </p:spPr>
+        <p:txBody>
+          <a:bodyPr wrap="square">
+            <a:spAutoFit/>
+          </a:bodyPr>
+          <a:lstStyle/>
+          <a:p>
+            <a:r>
+              <a:rPr lang="en-US" sz="1200" dirty="0" err="1">
+                <a:latin typeface="Arial" panose="020B0604020202020204" pitchFamily="34" charset="0"/>
+                <a:cs typeface="Arial" panose="020B0604020202020204" pitchFamily="34" charset="0"/>
+              </a:rPr>
+              <a:t>legend_kws</a:t>
+            </a:r>
+            <a:r>
+              <a:rPr lang="en-US" sz="1200" dirty="0">
+                <a:latin typeface="Arial" panose="020B0604020202020204" pitchFamily="34" charset="0"/>
+                <a:cs typeface="Arial" panose="020B0604020202020204" pitchFamily="34" charset="0"/>
+              </a:rPr>
+              <a:t>[‘height’]</a:t>
+            </a:r>
+          </a:p>
+        </p:txBody>
+      </p:sp>
     </p:spTree>
     <p:extLst>
       <p:ext uri="{BB962C8B-B14F-4D97-AF65-F5344CB8AC3E}">

</xml_diff>